<commit_message>
Keep the tester deck free of logins, and name An, Becca and Guillaume on a blank sign-off.
Co-authored-by: Cursor <cursoragent@cursor.com>
</commit_message>
<xml_diff>
--- a/docs/presentation/Gather-tester-guide.pptx
+++ b/docs/presentation/Gather-tester-guide.pptx
@@ -1353,7 +1353,7 @@
         </p:nvSpPr>
         <p:spPr>
           <a:xfrm>
-            <a:off x="640080" y="1554480"/>
+            <a:off x="640080" y="1691640"/>
             <a:ext cx="10972800" cy="822960"/>
           </a:xfrm>
           <a:prstGeom prst="rect">
@@ -1392,7 +1392,7 @@
         </p:nvSpPr>
         <p:spPr>
           <a:xfrm>
-            <a:off x="640080" y="2331720"/>
+            <a:off x="640080" y="2514600"/>
             <a:ext cx="10972800" cy="457200"/>
           </a:xfrm>
           <a:prstGeom prst="rect">
@@ -1417,7 +1417,7 @@
                 <a:ea typeface="Georgia" pitchFamily="34" charset="-122"/>
                 <a:cs typeface="Georgia" pitchFamily="34" charset="-120"/>
               </a:rPr>
-              <a:t>Tester guide</a:t>
+              <a:t>A quick look around</a:t>
             </a:r>
             <a:endParaRPr lang="en-US" sz="2800" dirty="0"/>
           </a:p>
@@ -1431,7 +1431,7 @@
         </p:nvSpPr>
         <p:spPr>
           <a:xfrm>
-            <a:off x="640080" y="3017520"/>
+            <a:off x="640080" y="3200400"/>
             <a:ext cx="9601200" cy="731520"/>
           </a:xfrm>
           <a:prstGeom prst="rect">
@@ -1448,7 +1448,7 @@
               <a:buNone/>
             </a:pPr>
             <a:r>
-              <a:rPr lang="en-US" sz="1800" dirty="0">
+              <a:rPr lang="en-US" sz="2000" dirty="0">
                 <a:solidFill>
                   <a:srgbClr val="4A4038"/>
                 </a:solidFill>
@@ -1456,9 +1456,9 @@
                 <a:ea typeface="Calibri" pitchFamily="34" charset="-122"/>
                 <a:cs typeface="Calibri" pitchFamily="34" charset="-120"/>
               </a:rPr>
-              <a:t>Closed calendar for one Birmingham community. Accounts are created by an admin. Members sign in with a cell number and password.</a:t>
-            </a:r>
-            <a:endParaRPr lang="en-US" sz="1800" dirty="0"/>
+              <a:t>A closed calendar for one community in Birmingham. Have a click. Nothing here is a test you can fail.</a:t>
+            </a:r>
+            <a:endParaRPr lang="en-US" sz="2000" dirty="0"/>
           </a:p>
         </p:txBody>
       </p:sp>
@@ -1470,7 +1470,7 @@
         </p:nvSpPr>
         <p:spPr>
           <a:xfrm>
-            <a:off x="640080" y="3977640"/>
+            <a:off x="640080" y="4206240"/>
             <a:ext cx="2743200" cy="256032"/>
           </a:xfrm>
           <a:prstGeom prst="rect">
@@ -1495,7 +1495,7 @@
                 <a:ea typeface="Calibri" pitchFamily="34" charset="-122"/>
                 <a:cs typeface="Calibri" pitchFamily="34" charset="-120"/>
               </a:rPr>
-              <a:t>Live demo</a:t>
+              <a:t>Open this</a:t>
             </a:r>
             <a:endParaRPr lang="en-US" sz="1300" dirty="0"/>
           </a:p>
@@ -1509,7 +1509,7 @@
         </p:nvSpPr>
         <p:spPr>
           <a:xfrm>
-            <a:off x="640080" y="4224528"/>
+            <a:off x="640080" y="4480560"/>
             <a:ext cx="10058400" cy="365760"/>
           </a:xfrm>
           <a:prstGeom prst="rect">
@@ -1537,45 +1537,6 @@
               <a:t>https://commseventsv1-production.up.railway.app</a:t>
             </a:r>
             <a:endParaRPr lang="en-US" sz="2000" dirty="0"/>
-          </a:p>
-        </p:txBody>
-      </p:sp>
-      <p:sp>
-        <p:nvSpPr>
-          <p:cNvPr id="8" name="Text 6"/>
-          <p:cNvSpPr/>
-          <p:nvPr/>
-        </p:nvSpPr>
-        <p:spPr>
-          <a:xfrm>
-            <a:off x="640080" y="6126480"/>
-            <a:ext cx="10515600" cy="274320"/>
-          </a:xfrm>
-          <a:prstGeom prst="rect">
-            <a:avLst/>
-          </a:prstGeom>
-          <a:noFill/>
-          <a:ln/>
-        </p:spPr>
-        <p:txBody>
-          <a:bodyPr wrap="square" rtlCol="0" anchor="ctr"/>
-          <a:lstStyle/>
-          <a:p>
-            <a:pPr indent="0" marL="0">
-              <a:buNone/>
-            </a:pPr>
-            <a:r>
-              <a:rPr lang="en-US" sz="1400" dirty="0">
-                <a:solidFill>
-                  <a:srgbClr val="4A4038"/>
-                </a:solidFill>
-                <a:latin typeface="Calibri" pitchFamily="34" charset="0"/>
-                <a:ea typeface="Calibri" pitchFamily="34" charset="-122"/>
-                <a:cs typeface="Calibri" pitchFamily="34" charset="-120"/>
-              </a:rPr>
-              <a:t>What it does: docs/FUNCTIONAL.md   ·   Weak points: docs/REVIEW.md   ·   17 October 2026</a:t>
-            </a:r>
-            <a:endParaRPr lang="en-US" sz="1400" dirty="0"/>
           </a:p>
         </p:txBody>
       </p:sp>
@@ -1658,24 +1619,24 @@
         </p:nvSpPr>
         <p:spPr>
           <a:xfrm>
-            <a:off x="457200" y="804672"/>
-            <a:ext cx="5852160" cy="502920"/>
-          </a:xfrm>
-          <a:prstGeom prst="rect">
-            <a:avLst/>
-          </a:prstGeom>
-          <a:noFill/>
-          <a:ln/>
-        </p:spPr>
-        <p:txBody>
-          <a:bodyPr wrap="square" rtlCol="0" anchor="ctr"/>
-          <a:lstStyle/>
-          <a:p>
-            <a:pPr indent="0" marL="0">
-              <a:buNone/>
-            </a:pPr>
-            <a:r>
-              <a:rPr lang="en-US" sz="1600" dirty="0">
+            <a:off x="457200" y="822960"/>
+            <a:ext cx="5852160" cy="640080"/>
+          </a:xfrm>
+          <a:prstGeom prst="rect">
+            <a:avLst/>
+          </a:prstGeom>
+          <a:noFill/>
+          <a:ln/>
+        </p:spPr>
+        <p:txBody>
+          <a:bodyPr wrap="square" rtlCol="0" anchor="ctr"/>
+          <a:lstStyle/>
+          <a:p>
+            <a:pPr indent="0" marL="0">
+              <a:buNone/>
+            </a:pPr>
+            <a:r>
+              <a:rPr lang="en-US" sz="1700" dirty="0">
                 <a:solidFill>
                   <a:srgbClr val="4A4038"/>
                 </a:solidFill>
@@ -1683,9 +1644,9 @@
                 <a:ea typeface="Calibri" pitchFamily="34" charset="-122"/>
                 <a:cs typeface="Calibri" pitchFamily="34" charset="-120"/>
               </a:rPr>
-              <a:t>Use the cell number and password your cell leader gave you. There is no public sign-up.</a:t>
-            </a:r>
-            <a:endParaRPr lang="en-US" sz="1600" dirty="0"/>
+              <a:t>Your cell leader gives you a cell number and a password. That is the whole door. There is no public sign-up.</a:t>
+            </a:r>
+            <a:endParaRPr lang="en-US" sz="1700" dirty="0"/>
           </a:p>
         </p:txBody>
       </p:sp>
@@ -1721,7 +1682,7 @@
         </p:nvSpPr>
         <p:spPr>
           <a:xfrm>
-            <a:off x="457200" y="1417320"/>
+            <a:off x="457200" y="1600200"/>
             <a:ext cx="5852160" cy="4434840"/>
           </a:xfrm>
           <a:prstGeom prst="roundRect">
@@ -1748,882 +1709,141 @@
         </p:nvSpPr>
         <p:spPr>
           <a:xfrm>
-            <a:off x="640080" y="1554480"/>
-            <a:ext cx="5486400" cy="320040"/>
-          </a:xfrm>
-          <a:prstGeom prst="rect">
-            <a:avLst/>
-          </a:prstGeom>
-          <a:noFill/>
-          <a:ln/>
-        </p:spPr>
-        <p:txBody>
-          <a:bodyPr wrap="square" rtlCol="0" anchor="ctr"/>
-          <a:lstStyle/>
-          <a:p>
-            <a:pPr indent="0" marL="0">
-              <a:buNone/>
-            </a:pPr>
-            <a:r>
-              <a:rPr lang="en-US" sz="1500" b="1" dirty="0">
-                <a:solidFill>
-                  <a:srgbClr val="1C1612"/>
+            <a:off x="685800" y="1828800"/>
+            <a:ext cx="5394960" cy="320040"/>
+          </a:xfrm>
+          <a:prstGeom prst="rect">
+            <a:avLst/>
+          </a:prstGeom>
+          <a:noFill/>
+          <a:ln/>
+        </p:spPr>
+        <p:txBody>
+          <a:bodyPr wrap="square" rtlCol="0" anchor="ctr"/>
+          <a:lstStyle/>
+          <a:p>
+            <a:pPr indent="0" marL="0">
+              <a:buNone/>
+            </a:pPr>
+            <a:r>
+              <a:rPr lang="en-US" sz="2000" b="1" dirty="0">
+                <a:solidFill>
+                  <a:srgbClr val="8B3A24"/>
+                </a:solidFill>
+                <a:latin typeface="Georgia" pitchFamily="34" charset="0"/>
+                <a:ea typeface="Georgia" pitchFamily="34" charset="-122"/>
+                <a:cs typeface="Georgia" pitchFamily="34" charset="-120"/>
+              </a:rPr>
+              <a:t>Members</a:t>
+            </a:r>
+            <a:endParaRPr lang="en-US" sz="2000" dirty="0"/>
+          </a:p>
+        </p:txBody>
+      </p:sp>
+      <p:sp>
+        <p:nvSpPr>
+          <p:cNvPr id="7" name="Text 4"/>
+          <p:cNvSpPr/>
+          <p:nvPr/>
+        </p:nvSpPr>
+        <p:spPr>
+          <a:xfrm>
+            <a:off x="685800" y="2176272"/>
+            <a:ext cx="5394960" cy="640080"/>
+          </a:xfrm>
+          <a:prstGeom prst="rect">
+            <a:avLst/>
+          </a:prstGeom>
+          <a:noFill/>
+          <a:ln/>
+        </p:spPr>
+        <p:txBody>
+          <a:bodyPr wrap="square" rtlCol="0" anchor="ctr"/>
+          <a:lstStyle/>
+          <a:p>
+            <a:pPr indent="0" marL="0">
+              <a:buNone/>
+            </a:pPr>
+            <a:r>
+              <a:rPr lang="en-US" sz="1600" dirty="0">
+                <a:solidFill>
+                  <a:srgbClr val="4A4038"/>
                 </a:solidFill>
                 <a:latin typeface="Calibri" pitchFamily="34" charset="0"/>
                 <a:ea typeface="Calibri" pitchFamily="34" charset="-122"/>
                 <a:cs typeface="Calibri" pitchFamily="34" charset="-120"/>
               </a:rPr>
-              <a:t>Demo accounts (this deployment only)</a:t>
-            </a:r>
-            <a:endParaRPr lang="en-US" sz="1500" dirty="0"/>
-          </a:p>
-        </p:txBody>
-      </p:sp>
-      <p:graphicFrame>
-        <p:nvGraphicFramePr>
-          <p:cNvPr id="3" name="Table 0"/>
-          <p:cNvGraphicFramePr>
-            <a:graphicFrameLocks noGrp="1"/>
-          </p:cNvGraphicFramePr>
-          <p:nvPr>
-            <p:extLst>
-              <p:ext uri="{D42A27DB-BD31-4B8C-83A1-F6EECF244321}">
-                <p14:modId xmlns:p14="http://schemas.microsoft.com/office/powerpoint/2010/main" val="1579011935"/>
-              </p:ext>
-            </p:extLst>
-          </p:nvPr>
-        </p:nvGraphicFramePr>
-        <p:xfrm>
-          <a:off x="640080" y="1965960"/>
-          <a:ext cx="5486400" cy="1920240"/>
-        </p:xfrm>
-        <a:graphic>
-          <a:graphicData uri="http://schemas.openxmlformats.org/drawingml/2006/table">
-            <a:tbl>
-              <a:tblPr/>
-              <a:tblGrid>
-                <a:gridCol w="1554480"/>
-                <a:gridCol w="2011680"/>
-                <a:gridCol w="1920240"/>
-              </a:tblGrid>
-              <a:tr h="480060">
-                <a:tc>
-                  <a:txBody>
-                    <a:bodyPr/>
-                    <a:lstStyle/>
-                    <a:p>
-                      <a:pPr indent="0" marL="0">
-                        <a:buNone/>
-                      </a:pPr>
-                      <a:r>
-                        <a:rPr lang="en-US" sz="1400" b="1" dirty="0">
-                          <a:solidFill>
-                            <a:srgbClr val="1C1612"/>
-                          </a:solidFill>
-                          <a:latin typeface="Calibri" pitchFamily="34" charset="0"/>
-                          <a:ea typeface="Calibri" pitchFamily="34" charset="-122"/>
-                          <a:cs typeface="Calibri" pitchFamily="34" charset="-120"/>
-                        </a:rPr>
-                        <a:t>Role</a:t>
-                      </a:r>
-                      <a:endParaRPr lang="en-US" sz="1400" dirty="0">
-                        <a:latin typeface="Calibri" charset="0"/>
-                        <a:ea typeface="Calibri" charset="0"/>
-                        <a:cs typeface="Calibri" charset="0"/>
-                      </a:endParaRPr>
-                    </a:p>
-                  </a:txBody>
-                  <a:tcPr marL="91440" marR="91440" marT="45720" marB="45720" anchor="ctr">
-                    <a:lnL w="12700" cap="flat" cmpd="sng" algn="ctr">
-                      <a:solidFill>
-                        <a:srgbClr val="666666"/>
-                      </a:solidFill>
-                      <a:prstDash val="solid"/>
-                      <a:round/>
-                      <a:headEnd type="none" w="med" len="med"/>
-                      <a:tailEnd type="none" w="med" len="med"/>
-                    </a:lnL>
-                    <a:lnR w="12700" cap="flat" cmpd="sng" algn="ctr">
-                      <a:solidFill>
-                        <a:srgbClr val="666666"/>
-                      </a:solidFill>
-                      <a:prstDash val="solid"/>
-                      <a:round/>
-                      <a:headEnd type="none" w="med" len="med"/>
-                      <a:tailEnd type="none" w="med" len="med"/>
-                    </a:lnR>
-                    <a:lnT w="12700" cap="flat" cmpd="sng" algn="ctr">
-                      <a:solidFill>
-                        <a:srgbClr val="666666"/>
-                      </a:solidFill>
-                      <a:prstDash val="solid"/>
-                      <a:round/>
-                      <a:headEnd type="none" w="med" len="med"/>
-                      <a:tailEnd type="none" w="med" len="med"/>
-                    </a:lnT>
-                    <a:lnB w="6350" cap="flat" cmpd="sng" algn="ctr">
-                      <a:solidFill>
-                        <a:srgbClr val="D9CBB6"/>
-                      </a:solidFill>
-                      <a:prstDash val="solid"/>
-                      <a:round/>
-                      <a:headEnd type="none" w="med" len="med"/>
-                      <a:tailEnd type="none" w="med" len="med"/>
-                    </a:lnB>
-                  </a:tcPr>
-                </a:tc>
-                <a:tc>
-                  <a:txBody>
-                    <a:bodyPr/>
-                    <a:lstStyle/>
-                    <a:p>
-                      <a:pPr indent="0" marL="0">
-                        <a:buNone/>
-                      </a:pPr>
-                      <a:r>
-                        <a:rPr lang="en-US" sz="1400" b="1" dirty="0">
-                          <a:solidFill>
-                            <a:srgbClr val="1C1612"/>
-                          </a:solidFill>
-                          <a:latin typeface="Calibri" pitchFamily="34" charset="0"/>
-                          <a:ea typeface="Calibri" pitchFamily="34" charset="-122"/>
-                          <a:cs typeface="Calibri" pitchFamily="34" charset="-120"/>
-                        </a:rPr>
-                        <a:t>Cell number</a:t>
-                      </a:r>
-                      <a:endParaRPr lang="en-US" sz="1400" dirty="0">
-                        <a:latin typeface="Calibri" charset="0"/>
-                        <a:ea typeface="Calibri" charset="0"/>
-                        <a:cs typeface="Calibri" charset="0"/>
-                      </a:endParaRPr>
-                    </a:p>
-                  </a:txBody>
-                  <a:tcPr marL="91440" marR="91440" marT="45720" marB="45720" anchor="ctr">
-                    <a:lnL w="12700" cap="flat" cmpd="sng" algn="ctr">
-                      <a:solidFill>
-                        <a:srgbClr val="666666"/>
-                      </a:solidFill>
-                      <a:prstDash val="solid"/>
-                      <a:round/>
-                      <a:headEnd type="none" w="med" len="med"/>
-                      <a:tailEnd type="none" w="med" len="med"/>
-                    </a:lnL>
-                    <a:lnR w="12700" cap="flat" cmpd="sng" algn="ctr">
-                      <a:solidFill>
-                        <a:srgbClr val="666666"/>
-                      </a:solidFill>
-                      <a:prstDash val="solid"/>
-                      <a:round/>
-                      <a:headEnd type="none" w="med" len="med"/>
-                      <a:tailEnd type="none" w="med" len="med"/>
-                    </a:lnR>
-                    <a:lnT w="12700" cap="flat" cmpd="sng" algn="ctr">
-                      <a:solidFill>
-                        <a:srgbClr val="666666"/>
-                      </a:solidFill>
-                      <a:prstDash val="solid"/>
-                      <a:round/>
-                      <a:headEnd type="none" w="med" len="med"/>
-                      <a:tailEnd type="none" w="med" len="med"/>
-                    </a:lnT>
-                    <a:lnB w="6350" cap="flat" cmpd="sng" algn="ctr">
-                      <a:solidFill>
-                        <a:srgbClr val="D9CBB6"/>
-                      </a:solidFill>
-                      <a:prstDash val="solid"/>
-                      <a:round/>
-                      <a:headEnd type="none" w="med" len="med"/>
-                      <a:tailEnd type="none" w="med" len="med"/>
-                    </a:lnB>
-                  </a:tcPr>
-                </a:tc>
-                <a:tc>
-                  <a:txBody>
-                    <a:bodyPr/>
-                    <a:lstStyle/>
-                    <a:p>
-                      <a:pPr indent="0" marL="0">
-                        <a:buNone/>
-                      </a:pPr>
-                      <a:r>
-                        <a:rPr lang="en-US" sz="1400" b="1" dirty="0">
-                          <a:solidFill>
-                            <a:srgbClr val="1C1612"/>
-                          </a:solidFill>
-                          <a:latin typeface="Calibri" pitchFamily="34" charset="0"/>
-                          <a:ea typeface="Calibri" pitchFamily="34" charset="-122"/>
-                          <a:cs typeface="Calibri" pitchFamily="34" charset="-120"/>
-                        </a:rPr>
-                        <a:t>Password</a:t>
-                      </a:r>
-                      <a:endParaRPr lang="en-US" sz="1400" dirty="0">
-                        <a:latin typeface="Calibri" charset="0"/>
-                        <a:ea typeface="Calibri" charset="0"/>
-                        <a:cs typeface="Calibri" charset="0"/>
-                      </a:endParaRPr>
-                    </a:p>
-                  </a:txBody>
-                  <a:tcPr marL="91440" marR="91440" marT="45720" marB="45720" anchor="ctr">
-                    <a:lnL w="12700" cap="flat" cmpd="sng" algn="ctr">
-                      <a:solidFill>
-                        <a:srgbClr val="666666"/>
-                      </a:solidFill>
-                      <a:prstDash val="solid"/>
-                      <a:round/>
-                      <a:headEnd type="none" w="med" len="med"/>
-                      <a:tailEnd type="none" w="med" len="med"/>
-                    </a:lnL>
-                    <a:lnR w="12700" cap="flat" cmpd="sng" algn="ctr">
-                      <a:solidFill>
-                        <a:srgbClr val="666666"/>
-                      </a:solidFill>
-                      <a:prstDash val="solid"/>
-                      <a:round/>
-                      <a:headEnd type="none" w="med" len="med"/>
-                      <a:tailEnd type="none" w="med" len="med"/>
-                    </a:lnR>
-                    <a:lnT w="12700" cap="flat" cmpd="sng" algn="ctr">
-                      <a:solidFill>
-                        <a:srgbClr val="666666"/>
-                      </a:solidFill>
-                      <a:prstDash val="solid"/>
-                      <a:round/>
-                      <a:headEnd type="none" w="med" len="med"/>
-                      <a:tailEnd type="none" w="med" len="med"/>
-                    </a:lnT>
-                    <a:lnB w="6350" cap="flat" cmpd="sng" algn="ctr">
-                      <a:solidFill>
-                        <a:srgbClr val="D9CBB6"/>
-                      </a:solidFill>
-                      <a:prstDash val="solid"/>
-                      <a:round/>
-                      <a:headEnd type="none" w="med" len="med"/>
-                      <a:tailEnd type="none" w="med" len="med"/>
-                    </a:lnB>
-                  </a:tcPr>
-                </a:tc>
-              </a:tr>
-              <a:tr h="480060">
-                <a:tc>
-                  <a:txBody>
-                    <a:bodyPr/>
-                    <a:lstStyle/>
-                    <a:p>
-                      <a:pPr indent="0" marL="0">
-                        <a:buNone/>
-                      </a:pPr>
-                      <a:r>
-                        <a:rPr lang="en-US" sz="1400" dirty="0">
-                          <a:solidFill>
-                            <a:srgbClr val="1C1612"/>
-                          </a:solidFill>
-                          <a:latin typeface="Calibri" pitchFamily="34" charset="0"/>
-                          <a:ea typeface="Calibri" pitchFamily="34" charset="-122"/>
-                          <a:cs typeface="Calibri" pitchFamily="34" charset="-120"/>
-                        </a:rPr>
-                        <a:t>Admin</a:t>
-                      </a:r>
-                      <a:endParaRPr lang="en-US" sz="1400" dirty="0">
-                        <a:latin typeface="Calibri" charset="0"/>
-                        <a:ea typeface="Calibri" charset="0"/>
-                        <a:cs typeface="Calibri" charset="0"/>
-                      </a:endParaRPr>
-                    </a:p>
-                  </a:txBody>
-                  <a:tcPr marL="91440" marR="91440" marT="45720" marB="45720" anchor="ctr">
-                    <a:lnL w="12700" cap="flat" cmpd="sng" algn="ctr">
-                      <a:solidFill>
-                        <a:srgbClr val="666666"/>
-                      </a:solidFill>
-                      <a:prstDash val="solid"/>
-                      <a:round/>
-                      <a:headEnd type="none" w="med" len="med"/>
-                      <a:tailEnd type="none" w="med" len="med"/>
-                    </a:lnL>
-                    <a:lnR w="12700" cap="flat" cmpd="sng" algn="ctr">
-                      <a:solidFill>
-                        <a:srgbClr val="666666"/>
-                      </a:solidFill>
-                      <a:prstDash val="solid"/>
-                      <a:round/>
-                      <a:headEnd type="none" w="med" len="med"/>
-                      <a:tailEnd type="none" w="med" len="med"/>
-                    </a:lnR>
-                    <a:lnT w="12700" cap="flat" cmpd="sng" algn="ctr">
-                      <a:solidFill>
-                        <a:srgbClr val="666666"/>
-                      </a:solidFill>
-                      <a:prstDash val="solid"/>
-                      <a:round/>
-                      <a:headEnd type="none" w="med" len="med"/>
-                      <a:tailEnd type="none" w="med" len="med"/>
-                    </a:lnT>
-                    <a:lnB w="6350" cap="flat" cmpd="sng" algn="ctr">
-                      <a:solidFill>
-                        <a:srgbClr val="D9CBB6"/>
-                      </a:solidFill>
-                      <a:prstDash val="solid"/>
-                      <a:round/>
-                      <a:headEnd type="none" w="med" len="med"/>
-                      <a:tailEnd type="none" w="med" len="med"/>
-                    </a:lnB>
-                  </a:tcPr>
-                </a:tc>
-                <a:tc>
-                  <a:txBody>
-                    <a:bodyPr/>
-                    <a:lstStyle/>
-                    <a:p>
-                      <a:pPr indent="0" marL="0">
-                        <a:buNone/>
-                      </a:pPr>
-                      <a:r>
-                        <a:rPr lang="en-US" sz="1400" dirty="0">
-                          <a:solidFill>
-                            <a:srgbClr val="1C1612"/>
-                          </a:solidFill>
-                          <a:latin typeface="Calibri" pitchFamily="34" charset="0"/>
-                          <a:ea typeface="Calibri" pitchFamily="34" charset="-122"/>
-                          <a:cs typeface="Calibri" pitchFamily="34" charset="-120"/>
-                        </a:rPr>
-                        <a:t>07000000001</a:t>
-                      </a:r>
-                      <a:endParaRPr lang="en-US" sz="1400" dirty="0">
-                        <a:latin typeface="Calibri" charset="0"/>
-                        <a:ea typeface="Calibri" charset="0"/>
-                        <a:cs typeface="Calibri" charset="0"/>
-                      </a:endParaRPr>
-                    </a:p>
-                  </a:txBody>
-                  <a:tcPr marL="91440" marR="91440" marT="45720" marB="45720" anchor="ctr">
-                    <a:lnL w="12700" cap="flat" cmpd="sng" algn="ctr">
-                      <a:solidFill>
-                        <a:srgbClr val="666666"/>
-                      </a:solidFill>
-                      <a:prstDash val="solid"/>
-                      <a:round/>
-                      <a:headEnd type="none" w="med" len="med"/>
-                      <a:tailEnd type="none" w="med" len="med"/>
-                    </a:lnL>
-                    <a:lnR w="12700" cap="flat" cmpd="sng" algn="ctr">
-                      <a:solidFill>
-                        <a:srgbClr val="666666"/>
-                      </a:solidFill>
-                      <a:prstDash val="solid"/>
-                      <a:round/>
-                      <a:headEnd type="none" w="med" len="med"/>
-                      <a:tailEnd type="none" w="med" len="med"/>
-                    </a:lnR>
-                    <a:lnT w="12700" cap="flat" cmpd="sng" algn="ctr">
-                      <a:solidFill>
-                        <a:srgbClr val="666666"/>
-                      </a:solidFill>
-                      <a:prstDash val="solid"/>
-                      <a:round/>
-                      <a:headEnd type="none" w="med" len="med"/>
-                      <a:tailEnd type="none" w="med" len="med"/>
-                    </a:lnT>
-                    <a:lnB w="6350" cap="flat" cmpd="sng" algn="ctr">
-                      <a:solidFill>
-                        <a:srgbClr val="D9CBB6"/>
-                      </a:solidFill>
-                      <a:prstDash val="solid"/>
-                      <a:round/>
-                      <a:headEnd type="none" w="med" len="med"/>
-                      <a:tailEnd type="none" w="med" len="med"/>
-                    </a:lnB>
-                  </a:tcPr>
-                </a:tc>
-                <a:tc>
-                  <a:txBody>
-                    <a:bodyPr/>
-                    <a:lstStyle/>
-                    <a:p>
-                      <a:pPr indent="0" marL="0">
-                        <a:buNone/>
-                      </a:pPr>
-                      <a:r>
-                        <a:rPr lang="en-US" sz="1400" dirty="0">
-                          <a:solidFill>
-                            <a:srgbClr val="1C1612"/>
-                          </a:solidFill>
-                          <a:latin typeface="Calibri" pitchFamily="34" charset="0"/>
-                          <a:ea typeface="Calibri" pitchFamily="34" charset="-122"/>
-                          <a:cs typeface="Calibri" pitchFamily="34" charset="-120"/>
-                        </a:rPr>
-                        <a:t>AdminPass1</a:t>
-                      </a:r>
-                      <a:endParaRPr lang="en-US" sz="1400" dirty="0">
-                        <a:latin typeface="Calibri" charset="0"/>
-                        <a:ea typeface="Calibri" charset="0"/>
-                        <a:cs typeface="Calibri" charset="0"/>
-                      </a:endParaRPr>
-                    </a:p>
-                  </a:txBody>
-                  <a:tcPr marL="91440" marR="91440" marT="45720" marB="45720" anchor="ctr">
-                    <a:lnL w="12700" cap="flat" cmpd="sng" algn="ctr">
-                      <a:solidFill>
-                        <a:srgbClr val="666666"/>
-                      </a:solidFill>
-                      <a:prstDash val="solid"/>
-                      <a:round/>
-                      <a:headEnd type="none" w="med" len="med"/>
-                      <a:tailEnd type="none" w="med" len="med"/>
-                    </a:lnL>
-                    <a:lnR w="12700" cap="flat" cmpd="sng" algn="ctr">
-                      <a:solidFill>
-                        <a:srgbClr val="666666"/>
-                      </a:solidFill>
-                      <a:prstDash val="solid"/>
-                      <a:round/>
-                      <a:headEnd type="none" w="med" len="med"/>
-                      <a:tailEnd type="none" w="med" len="med"/>
-                    </a:lnR>
-                    <a:lnT w="12700" cap="flat" cmpd="sng" algn="ctr">
-                      <a:solidFill>
-                        <a:srgbClr val="666666"/>
-                      </a:solidFill>
-                      <a:prstDash val="solid"/>
-                      <a:round/>
-                      <a:headEnd type="none" w="med" len="med"/>
-                      <a:tailEnd type="none" w="med" len="med"/>
-                    </a:lnT>
-                    <a:lnB w="6350" cap="flat" cmpd="sng" algn="ctr">
-                      <a:solidFill>
-                        <a:srgbClr val="D9CBB6"/>
-                      </a:solidFill>
-                      <a:prstDash val="solid"/>
-                      <a:round/>
-                      <a:headEnd type="none" w="med" len="med"/>
-                      <a:tailEnd type="none" w="med" len="med"/>
-                    </a:lnB>
-                  </a:tcPr>
-                </a:tc>
-              </a:tr>
-              <a:tr h="480060">
-                <a:tc>
-                  <a:txBody>
-                    <a:bodyPr/>
-                    <a:lstStyle/>
-                    <a:p>
-                      <a:pPr indent="0" marL="0">
-                        <a:buNone/>
-                      </a:pPr>
-                      <a:r>
-                        <a:rPr lang="en-US" sz="1400" dirty="0">
-                          <a:solidFill>
-                            <a:srgbClr val="1C1612"/>
-                          </a:solidFill>
-                          <a:latin typeface="Calibri" pitchFamily="34" charset="0"/>
-                          <a:ea typeface="Calibri" pitchFamily="34" charset="-122"/>
-                          <a:cs typeface="Calibri" pitchFamily="34" charset="-120"/>
-                        </a:rPr>
-                        <a:t>Cell leader</a:t>
-                      </a:r>
-                      <a:endParaRPr lang="en-US" sz="1400" dirty="0">
-                        <a:latin typeface="Calibri" charset="0"/>
-                        <a:ea typeface="Calibri" charset="0"/>
-                        <a:cs typeface="Calibri" charset="0"/>
-                      </a:endParaRPr>
-                    </a:p>
-                  </a:txBody>
-                  <a:tcPr marL="91440" marR="91440" marT="45720" marB="45720" anchor="ctr">
-                    <a:lnL w="12700" cap="flat" cmpd="sng" algn="ctr">
-                      <a:solidFill>
-                        <a:srgbClr val="666666"/>
-                      </a:solidFill>
-                      <a:prstDash val="solid"/>
-                      <a:round/>
-                      <a:headEnd type="none" w="med" len="med"/>
-                      <a:tailEnd type="none" w="med" len="med"/>
-                    </a:lnL>
-                    <a:lnR w="12700" cap="flat" cmpd="sng" algn="ctr">
-                      <a:solidFill>
-                        <a:srgbClr val="666666"/>
-                      </a:solidFill>
-                      <a:prstDash val="solid"/>
-                      <a:round/>
-                      <a:headEnd type="none" w="med" len="med"/>
-                      <a:tailEnd type="none" w="med" len="med"/>
-                    </a:lnR>
-                    <a:lnT w="12700" cap="flat" cmpd="sng" algn="ctr">
-                      <a:solidFill>
-                        <a:srgbClr val="666666"/>
-                      </a:solidFill>
-                      <a:prstDash val="solid"/>
-                      <a:round/>
-                      <a:headEnd type="none" w="med" len="med"/>
-                      <a:tailEnd type="none" w="med" len="med"/>
-                    </a:lnT>
-                    <a:lnB w="6350" cap="flat" cmpd="sng" algn="ctr">
-                      <a:solidFill>
-                        <a:srgbClr val="D9CBB6"/>
-                      </a:solidFill>
-                      <a:prstDash val="solid"/>
-                      <a:round/>
-                      <a:headEnd type="none" w="med" len="med"/>
-                      <a:tailEnd type="none" w="med" len="med"/>
-                    </a:lnB>
-                  </a:tcPr>
-                </a:tc>
-                <a:tc>
-                  <a:txBody>
-                    <a:bodyPr/>
-                    <a:lstStyle/>
-                    <a:p>
-                      <a:pPr indent="0" marL="0">
-                        <a:buNone/>
-                      </a:pPr>
-                      <a:r>
-                        <a:rPr lang="en-US" sz="1400" dirty="0">
-                          <a:solidFill>
-                            <a:srgbClr val="1C1612"/>
-                          </a:solidFill>
-                          <a:latin typeface="Calibri" pitchFamily="34" charset="0"/>
-                          <a:ea typeface="Calibri" pitchFamily="34" charset="-122"/>
-                          <a:cs typeface="Calibri" pitchFamily="34" charset="-120"/>
-                        </a:rPr>
-                        <a:t>07000000002</a:t>
-                      </a:r>
-                      <a:endParaRPr lang="en-US" sz="1400" dirty="0">
-                        <a:latin typeface="Calibri" charset="0"/>
-                        <a:ea typeface="Calibri" charset="0"/>
-                        <a:cs typeface="Calibri" charset="0"/>
-                      </a:endParaRPr>
-                    </a:p>
-                  </a:txBody>
-                  <a:tcPr marL="91440" marR="91440" marT="45720" marB="45720" anchor="ctr">
-                    <a:lnL w="12700" cap="flat" cmpd="sng" algn="ctr">
-                      <a:solidFill>
-                        <a:srgbClr val="666666"/>
-                      </a:solidFill>
-                      <a:prstDash val="solid"/>
-                      <a:round/>
-                      <a:headEnd type="none" w="med" len="med"/>
-                      <a:tailEnd type="none" w="med" len="med"/>
-                    </a:lnL>
-                    <a:lnR w="12700" cap="flat" cmpd="sng" algn="ctr">
-                      <a:solidFill>
-                        <a:srgbClr val="666666"/>
-                      </a:solidFill>
-                      <a:prstDash val="solid"/>
-                      <a:round/>
-                      <a:headEnd type="none" w="med" len="med"/>
-                      <a:tailEnd type="none" w="med" len="med"/>
-                    </a:lnR>
-                    <a:lnT w="12700" cap="flat" cmpd="sng" algn="ctr">
-                      <a:solidFill>
-                        <a:srgbClr val="666666"/>
-                      </a:solidFill>
-                      <a:prstDash val="solid"/>
-                      <a:round/>
-                      <a:headEnd type="none" w="med" len="med"/>
-                      <a:tailEnd type="none" w="med" len="med"/>
-                    </a:lnT>
-                    <a:lnB w="6350" cap="flat" cmpd="sng" algn="ctr">
-                      <a:solidFill>
-                        <a:srgbClr val="D9CBB6"/>
-                      </a:solidFill>
-                      <a:prstDash val="solid"/>
-                      <a:round/>
-                      <a:headEnd type="none" w="med" len="med"/>
-                      <a:tailEnd type="none" w="med" len="med"/>
-                    </a:lnB>
-                  </a:tcPr>
-                </a:tc>
-                <a:tc>
-                  <a:txBody>
-                    <a:bodyPr/>
-                    <a:lstStyle/>
-                    <a:p>
-                      <a:pPr indent="0" marL="0">
-                        <a:buNone/>
-                      </a:pPr>
-                      <a:r>
-                        <a:rPr lang="en-US" sz="1400" dirty="0">
-                          <a:solidFill>
-                            <a:srgbClr val="1C1612"/>
-                          </a:solidFill>
-                          <a:latin typeface="Calibri" pitchFamily="34" charset="0"/>
-                          <a:ea typeface="Calibri" pitchFamily="34" charset="-122"/>
-                          <a:cs typeface="Calibri" pitchFamily="34" charset="-120"/>
-                        </a:rPr>
-                        <a:t>LeaderPass1</a:t>
-                      </a:r>
-                      <a:endParaRPr lang="en-US" sz="1400" dirty="0">
-                        <a:latin typeface="Calibri" charset="0"/>
-                        <a:ea typeface="Calibri" charset="0"/>
-                        <a:cs typeface="Calibri" charset="0"/>
-                      </a:endParaRPr>
-                    </a:p>
-                  </a:txBody>
-                  <a:tcPr marL="91440" marR="91440" marT="45720" marB="45720" anchor="ctr">
-                    <a:lnL w="12700" cap="flat" cmpd="sng" algn="ctr">
-                      <a:solidFill>
-                        <a:srgbClr val="666666"/>
-                      </a:solidFill>
-                      <a:prstDash val="solid"/>
-                      <a:round/>
-                      <a:headEnd type="none" w="med" len="med"/>
-                      <a:tailEnd type="none" w="med" len="med"/>
-                    </a:lnL>
-                    <a:lnR w="12700" cap="flat" cmpd="sng" algn="ctr">
-                      <a:solidFill>
-                        <a:srgbClr val="666666"/>
-                      </a:solidFill>
-                      <a:prstDash val="solid"/>
-                      <a:round/>
-                      <a:headEnd type="none" w="med" len="med"/>
-                      <a:tailEnd type="none" w="med" len="med"/>
-                    </a:lnR>
-                    <a:lnT w="12700" cap="flat" cmpd="sng" algn="ctr">
-                      <a:solidFill>
-                        <a:srgbClr val="666666"/>
-                      </a:solidFill>
-                      <a:prstDash val="solid"/>
-                      <a:round/>
-                      <a:headEnd type="none" w="med" len="med"/>
-                      <a:tailEnd type="none" w="med" len="med"/>
-                    </a:lnT>
-                    <a:lnB w="6350" cap="flat" cmpd="sng" algn="ctr">
-                      <a:solidFill>
-                        <a:srgbClr val="D9CBB6"/>
-                      </a:solidFill>
-                      <a:prstDash val="solid"/>
-                      <a:round/>
-                      <a:headEnd type="none" w="med" len="med"/>
-                      <a:tailEnd type="none" w="med" len="med"/>
-                    </a:lnB>
-                  </a:tcPr>
-                </a:tc>
-              </a:tr>
-              <a:tr h="480060">
-                <a:tc>
-                  <a:txBody>
-                    <a:bodyPr/>
-                    <a:lstStyle/>
-                    <a:p>
-                      <a:pPr indent="0" marL="0">
-                        <a:buNone/>
-                      </a:pPr>
-                      <a:r>
-                        <a:rPr lang="en-US" sz="1400" dirty="0">
-                          <a:solidFill>
-                            <a:srgbClr val="1C1612"/>
-                          </a:solidFill>
-                          <a:latin typeface="Calibri" pitchFamily="34" charset="0"/>
-                          <a:ea typeface="Calibri" pitchFamily="34" charset="-122"/>
-                          <a:cs typeface="Calibri" pitchFamily="34" charset="-120"/>
-                        </a:rPr>
-                        <a:t>Member</a:t>
-                      </a:r>
-                      <a:endParaRPr lang="en-US" sz="1400" dirty="0">
-                        <a:latin typeface="Calibri" charset="0"/>
-                        <a:ea typeface="Calibri" charset="0"/>
-                        <a:cs typeface="Calibri" charset="0"/>
-                      </a:endParaRPr>
-                    </a:p>
-                  </a:txBody>
-                  <a:tcPr marL="91440" marR="91440" marT="45720" marB="45720" anchor="ctr">
-                    <a:lnL w="12700" cap="flat" cmpd="sng" algn="ctr">
-                      <a:solidFill>
-                        <a:srgbClr val="666666"/>
-                      </a:solidFill>
-                      <a:prstDash val="solid"/>
-                      <a:round/>
-                      <a:headEnd type="none" w="med" len="med"/>
-                      <a:tailEnd type="none" w="med" len="med"/>
-                    </a:lnL>
-                    <a:lnR w="12700" cap="flat" cmpd="sng" algn="ctr">
-                      <a:solidFill>
-                        <a:srgbClr val="666666"/>
-                      </a:solidFill>
-                      <a:prstDash val="solid"/>
-                      <a:round/>
-                      <a:headEnd type="none" w="med" len="med"/>
-                      <a:tailEnd type="none" w="med" len="med"/>
-                    </a:lnR>
-                    <a:lnT w="12700" cap="flat" cmpd="sng" algn="ctr">
-                      <a:solidFill>
-                        <a:srgbClr val="666666"/>
-                      </a:solidFill>
-                      <a:prstDash val="solid"/>
-                      <a:round/>
-                      <a:headEnd type="none" w="med" len="med"/>
-                      <a:tailEnd type="none" w="med" len="med"/>
-                    </a:lnT>
-                    <a:lnB w="6350" cap="flat" cmpd="sng" algn="ctr">
-                      <a:solidFill>
-                        <a:srgbClr val="D9CBB6"/>
-                      </a:solidFill>
-                      <a:prstDash val="solid"/>
-                      <a:round/>
-                      <a:headEnd type="none" w="med" len="med"/>
-                      <a:tailEnd type="none" w="med" len="med"/>
-                    </a:lnB>
-                  </a:tcPr>
-                </a:tc>
-                <a:tc>
-                  <a:txBody>
-                    <a:bodyPr/>
-                    <a:lstStyle/>
-                    <a:p>
-                      <a:pPr indent="0" marL="0">
-                        <a:buNone/>
-                      </a:pPr>
-                      <a:r>
-                        <a:rPr lang="en-US" sz="1400" dirty="0">
-                          <a:solidFill>
-                            <a:srgbClr val="1C1612"/>
-                          </a:solidFill>
-                          <a:latin typeface="Calibri" pitchFamily="34" charset="0"/>
-                          <a:ea typeface="Calibri" pitchFamily="34" charset="-122"/>
-                          <a:cs typeface="Calibri" pitchFamily="34" charset="-120"/>
-                        </a:rPr>
-                        <a:t>07000000004</a:t>
-                      </a:r>
-                      <a:endParaRPr lang="en-US" sz="1400" dirty="0">
-                        <a:latin typeface="Calibri" charset="0"/>
-                        <a:ea typeface="Calibri" charset="0"/>
-                        <a:cs typeface="Calibri" charset="0"/>
-                      </a:endParaRPr>
-                    </a:p>
-                  </a:txBody>
-                  <a:tcPr marL="91440" marR="91440" marT="45720" marB="45720" anchor="ctr">
-                    <a:lnL w="12700" cap="flat" cmpd="sng" algn="ctr">
-                      <a:solidFill>
-                        <a:srgbClr val="666666"/>
-                      </a:solidFill>
-                      <a:prstDash val="solid"/>
-                      <a:round/>
-                      <a:headEnd type="none" w="med" len="med"/>
-                      <a:tailEnd type="none" w="med" len="med"/>
-                    </a:lnL>
-                    <a:lnR w="12700" cap="flat" cmpd="sng" algn="ctr">
-                      <a:solidFill>
-                        <a:srgbClr val="666666"/>
-                      </a:solidFill>
-                      <a:prstDash val="solid"/>
-                      <a:round/>
-                      <a:headEnd type="none" w="med" len="med"/>
-                      <a:tailEnd type="none" w="med" len="med"/>
-                    </a:lnR>
-                    <a:lnT w="12700" cap="flat" cmpd="sng" algn="ctr">
-                      <a:solidFill>
-                        <a:srgbClr val="666666"/>
-                      </a:solidFill>
-                      <a:prstDash val="solid"/>
-                      <a:round/>
-                      <a:headEnd type="none" w="med" len="med"/>
-                      <a:tailEnd type="none" w="med" len="med"/>
-                    </a:lnT>
-                    <a:lnB w="6350" cap="flat" cmpd="sng" algn="ctr">
-                      <a:solidFill>
-                        <a:srgbClr val="D9CBB6"/>
-                      </a:solidFill>
-                      <a:prstDash val="solid"/>
-                      <a:round/>
-                      <a:headEnd type="none" w="med" len="med"/>
-                      <a:tailEnd type="none" w="med" len="med"/>
-                    </a:lnB>
-                  </a:tcPr>
-                </a:tc>
-                <a:tc>
-                  <a:txBody>
-                    <a:bodyPr/>
-                    <a:lstStyle/>
-                    <a:p>
-                      <a:pPr indent="0" marL="0">
-                        <a:buNone/>
-                      </a:pPr>
-                      <a:r>
-                        <a:rPr lang="en-US" sz="1400" dirty="0">
-                          <a:solidFill>
-                            <a:srgbClr val="1C1612"/>
-                          </a:solidFill>
-                          <a:latin typeface="Calibri" pitchFamily="34" charset="0"/>
-                          <a:ea typeface="Calibri" pitchFamily="34" charset="-122"/>
-                          <a:cs typeface="Calibri" pitchFamily="34" charset="-120"/>
-                        </a:rPr>
-                        <a:t>MemberPass1</a:t>
-                      </a:r>
-                      <a:endParaRPr lang="en-US" sz="1400" dirty="0">
-                        <a:latin typeface="Calibri" charset="0"/>
-                        <a:ea typeface="Calibri" charset="0"/>
-                        <a:cs typeface="Calibri" charset="0"/>
-                      </a:endParaRPr>
-                    </a:p>
-                  </a:txBody>
-                  <a:tcPr marL="91440" marR="91440" marT="45720" marB="45720" anchor="ctr">
-                    <a:lnL w="12700" cap="flat" cmpd="sng" algn="ctr">
-                      <a:solidFill>
-                        <a:srgbClr val="666666"/>
-                      </a:solidFill>
-                      <a:prstDash val="solid"/>
-                      <a:round/>
-                      <a:headEnd type="none" w="med" len="med"/>
-                      <a:tailEnd type="none" w="med" len="med"/>
-                    </a:lnL>
-                    <a:lnR w="12700" cap="flat" cmpd="sng" algn="ctr">
-                      <a:solidFill>
-                        <a:srgbClr val="666666"/>
-                      </a:solidFill>
-                      <a:prstDash val="solid"/>
-                      <a:round/>
-                      <a:headEnd type="none" w="med" len="med"/>
-                      <a:tailEnd type="none" w="med" len="med"/>
-                    </a:lnR>
-                    <a:lnT w="12700" cap="flat" cmpd="sng" algn="ctr">
-                      <a:solidFill>
-                        <a:srgbClr val="666666"/>
-                      </a:solidFill>
-                      <a:prstDash val="solid"/>
-                      <a:round/>
-                      <a:headEnd type="none" w="med" len="med"/>
-                      <a:tailEnd type="none" w="med" len="med"/>
-                    </a:lnT>
-                    <a:lnB w="6350" cap="flat" cmpd="sng" algn="ctr">
-                      <a:solidFill>
-                        <a:srgbClr val="D9CBB6"/>
-                      </a:solidFill>
-                      <a:prstDash val="solid"/>
-                      <a:round/>
-                      <a:headEnd type="none" w="med" len="med"/>
-                      <a:tailEnd type="none" w="med" len="med"/>
-                    </a:lnB>
-                  </a:tcPr>
-                </a:tc>
-              </a:tr>
-            </a:tbl>
-          </a:graphicData>
-        </a:graphic>
-      </p:graphicFrame>
-      <p:sp>
-        <p:nvSpPr>
-          <p:cNvPr id="8" name="Text 4"/>
-          <p:cNvSpPr/>
-          <p:nvPr/>
-        </p:nvSpPr>
-        <p:spPr>
-          <a:xfrm>
-            <a:off x="640080" y="4023360"/>
-            <a:ext cx="5486400" cy="1463040"/>
-          </a:xfrm>
-          <a:prstGeom prst="rect">
-            <a:avLst/>
-          </a:prstGeom>
-          <a:noFill/>
-          <a:ln/>
-        </p:spPr>
-        <p:txBody>
-          <a:bodyPr wrap="square" rtlCol="0" anchor="ctr"/>
-          <a:lstStyle/>
-          <a:p>
-            <a:pPr indent="0" marL="0">
-              <a:buNone/>
-            </a:pPr>
-            <a:r>
-              <a:rPr lang="en-US" sz="1500" dirty="0">
+              <a:t>Browse the calendar, click Attend, confirm later if you went.</a:t>
+            </a:r>
+            <a:endParaRPr lang="en-US" sz="1600" dirty="0"/>
+          </a:p>
+        </p:txBody>
+      </p:sp>
+      <p:sp>
+        <p:nvSpPr>
+          <p:cNvPr id="8" name="Text 5"/>
+          <p:cNvSpPr/>
+          <p:nvPr/>
+        </p:nvSpPr>
+        <p:spPr>
+          <a:xfrm>
+            <a:off x="685800" y="3108960"/>
+            <a:ext cx="5394960" cy="320040"/>
+          </a:xfrm>
+          <a:prstGeom prst="rect">
+            <a:avLst/>
+          </a:prstGeom>
+          <a:noFill/>
+          <a:ln/>
+        </p:spPr>
+        <p:txBody>
+          <a:bodyPr wrap="square" rtlCol="0" anchor="ctr"/>
+          <a:lstStyle/>
+          <a:p>
+            <a:pPr indent="0" marL="0">
+              <a:buNone/>
+            </a:pPr>
+            <a:r>
+              <a:rPr lang="en-US" sz="2000" b="1" dirty="0">
+                <a:solidFill>
+                  <a:srgbClr val="8B3A24"/>
+                </a:solidFill>
+                <a:latin typeface="Georgia" pitchFamily="34" charset="0"/>
+                <a:ea typeface="Georgia" pitchFamily="34" charset="-122"/>
+                <a:cs typeface="Georgia" pitchFamily="34" charset="-120"/>
+              </a:rPr>
+              <a:t>Cell leaders</a:t>
+            </a:r>
+            <a:endParaRPr lang="en-US" sz="2000" dirty="0"/>
+          </a:p>
+        </p:txBody>
+      </p:sp>
+      <p:sp>
+        <p:nvSpPr>
+          <p:cNvPr id="9" name="Text 6"/>
+          <p:cNvSpPr/>
+          <p:nvPr/>
+        </p:nvSpPr>
+        <p:spPr>
+          <a:xfrm>
+            <a:off x="685800" y="3456432"/>
+            <a:ext cx="5394960" cy="640080"/>
+          </a:xfrm>
+          <a:prstGeom prst="rect">
+            <a:avLst/>
+          </a:prstGeom>
+          <a:noFill/>
+          <a:ln/>
+        </p:spPr>
+        <p:txBody>
+          <a:bodyPr wrap="square" rtlCol="0" anchor="ctr"/>
+          <a:lstStyle/>
+          <a:p>
+            <a:pPr indent="0" marL="0">
+              <a:buNone/>
+            </a:pPr>
+            <a:r>
+              <a:rPr lang="en-US" sz="1600" dirty="0">
                 <a:solidFill>
                   <a:srgbClr val="4A4038"/>
                 </a:solidFill>
@@ -2631,38 +1851,77 @@
                 <a:ea typeface="Calibri" pitchFamily="34" charset="-122"/>
                 <a:cs typeface="Calibri" pitchFamily="34" charset="-120"/>
               </a:rPr>
-              <a:t>Admin sees every page. Cell leaders see Insights for their own cell, pending review, and their members. Members see the calendar, bookings, and Attend.</a:t>
-            </a:r>
-            <a:endParaRPr lang="en-US" sz="1500" dirty="0"/>
-          </a:p>
-        </p:txBody>
-      </p:sp>
-      <p:sp>
-        <p:nvSpPr>
-          <p:cNvPr id="9" name="Text 5"/>
-          <p:cNvSpPr/>
-          <p:nvPr/>
-        </p:nvSpPr>
-        <p:spPr>
-          <a:xfrm>
-            <a:off x="457200" y="6510528"/>
-            <a:ext cx="9601200" cy="201168"/>
-          </a:xfrm>
-          <a:prstGeom prst="rect">
-            <a:avLst/>
-          </a:prstGeom>
-          <a:noFill/>
-          <a:ln/>
-        </p:spPr>
-        <p:txBody>
-          <a:bodyPr wrap="square" rtlCol="0" anchor="ctr"/>
-          <a:lstStyle/>
-          <a:p>
-            <a:pPr indent="0" marL="0">
-              <a:buNone/>
-            </a:pPr>
-            <a:r>
-              <a:rPr lang="en-US" sz="1100" dirty="0">
+              <a:t>Look after their own cell, review pending events, see Insights for that cell.</a:t>
+            </a:r>
+            <a:endParaRPr lang="en-US" sz="1600" dirty="0"/>
+          </a:p>
+        </p:txBody>
+      </p:sp>
+      <p:sp>
+        <p:nvSpPr>
+          <p:cNvPr id="10" name="Text 7"/>
+          <p:cNvSpPr/>
+          <p:nvPr/>
+        </p:nvSpPr>
+        <p:spPr>
+          <a:xfrm>
+            <a:off x="685800" y="4389120"/>
+            <a:ext cx="5394960" cy="320040"/>
+          </a:xfrm>
+          <a:prstGeom prst="rect">
+            <a:avLst/>
+          </a:prstGeom>
+          <a:noFill/>
+          <a:ln/>
+        </p:spPr>
+        <p:txBody>
+          <a:bodyPr wrap="square" rtlCol="0" anchor="ctr"/>
+          <a:lstStyle/>
+          <a:p>
+            <a:pPr indent="0" marL="0">
+              <a:buNone/>
+            </a:pPr>
+            <a:r>
+              <a:rPr lang="en-US" sz="2000" b="1" dirty="0">
+                <a:solidFill>
+                  <a:srgbClr val="8B3A24"/>
+                </a:solidFill>
+                <a:latin typeface="Georgia" pitchFamily="34" charset="0"/>
+                <a:ea typeface="Georgia" pitchFamily="34" charset="-122"/>
+                <a:cs typeface="Georgia" pitchFamily="34" charset="-120"/>
+              </a:rPr>
+              <a:t>Admin</a:t>
+            </a:r>
+            <a:endParaRPr lang="en-US" sz="2000" dirty="0"/>
+          </a:p>
+        </p:txBody>
+      </p:sp>
+      <p:sp>
+        <p:nvSpPr>
+          <p:cNvPr id="11" name="Text 8"/>
+          <p:cNvSpPr/>
+          <p:nvPr/>
+        </p:nvSpPr>
+        <p:spPr>
+          <a:xfrm>
+            <a:off x="685800" y="4736592"/>
+            <a:ext cx="5394960" cy="640080"/>
+          </a:xfrm>
+          <a:prstGeom prst="rect">
+            <a:avLst/>
+          </a:prstGeom>
+          <a:noFill/>
+          <a:ln/>
+        </p:spPr>
+        <p:txBody>
+          <a:bodyPr wrap="square" rtlCol="0" anchor="ctr"/>
+          <a:lstStyle/>
+          <a:p>
+            <a:pPr indent="0" marL="0">
+              <a:buNone/>
+            </a:pPr>
+            <a:r>
+              <a:rPr lang="en-US" sz="1600" dirty="0">
                 <a:solidFill>
                   <a:srgbClr val="4A4038"/>
                 </a:solidFill>
@@ -2670,7 +1929,46 @@
                 <a:ea typeface="Calibri" pitchFamily="34" charset="-122"/>
                 <a:cs typeface="Calibri" pitchFamily="34" charset="-120"/>
               </a:rPr>
-              <a:t>Gather  ·  Birmingham  ·  17 October 2026</a:t>
+              <a:t>Sets people up, runs the scraper, sees the whole region.</a:t>
+            </a:r>
+            <a:endParaRPr lang="en-US" sz="1600" dirty="0"/>
+          </a:p>
+        </p:txBody>
+      </p:sp>
+      <p:sp>
+        <p:nvSpPr>
+          <p:cNvPr id="12" name="Text 9"/>
+          <p:cNvSpPr/>
+          <p:nvPr/>
+        </p:nvSpPr>
+        <p:spPr>
+          <a:xfrm>
+            <a:off x="457200" y="6510528"/>
+            <a:ext cx="9601200" cy="201168"/>
+          </a:xfrm>
+          <a:prstGeom prst="rect">
+            <a:avLst/>
+          </a:prstGeom>
+          <a:noFill/>
+          <a:ln/>
+        </p:spPr>
+        <p:txBody>
+          <a:bodyPr wrap="square" rtlCol="0" anchor="ctr"/>
+          <a:lstStyle/>
+          <a:p>
+            <a:pPr indent="0" marL="0">
+              <a:buNone/>
+            </a:pPr>
+            <a:r>
+              <a:rPr lang="en-US" sz="1100" dirty="0">
+                <a:solidFill>
+                  <a:srgbClr val="4A4038"/>
+                </a:solidFill>
+                <a:latin typeface="Calibri" pitchFamily="34" charset="0"/>
+                <a:ea typeface="Calibri" pitchFamily="34" charset="-122"/>
+                <a:cs typeface="Calibri" pitchFamily="34" charset="-120"/>
+              </a:rPr>
+              <a:t>Gather  ·  Birmingham</a:t>
             </a:r>
             <a:endParaRPr lang="en-US" sz="1100" dirty="0"/>
           </a:p>
@@ -2678,7 +1976,7 @@
       </p:sp>
       <p:sp>
         <p:nvSpPr>
-          <p:cNvPr id="10" name="Text 6"/>
+          <p:cNvPr id="13" name="Text 10"/>
           <p:cNvSpPr/>
           <p:nvPr/>
         </p:nvSpPr>
@@ -2780,7 +2078,7 @@
                 <a:ea typeface="Georgia" pitchFamily="34" charset="-122"/>
                 <a:cs typeface="Georgia" pitchFamily="34" charset="-120"/>
               </a:rPr>
-              <a:t>Find an event</a:t>
+              <a:t>Find something</a:t>
             </a:r>
             <a:endParaRPr lang="en-US" sz="2800" dirty="0"/>
           </a:p>
@@ -2811,7 +2109,7 @@
               <a:buNone/>
             </a:pPr>
             <a:r>
-              <a:rPr lang="en-US" sz="1600" dirty="0">
+              <a:rPr lang="en-US" sz="1700" dirty="0">
                 <a:solidFill>
                   <a:srgbClr val="4A4038"/>
                 </a:solidFill>
@@ -2819,9 +2117,9 @@
                 <a:ea typeface="Calibri" pitchFamily="34" charset="-122"/>
                 <a:cs typeface="Calibri" pitchFamily="34" charset="-120"/>
               </a:rPr>
-              <a:t>Month, week and day follow the date you pick. All types and Any format clear the filter. The map stays on the page.</a:t>
-            </a:r>
-            <a:endParaRPr lang="en-US" sz="1600" dirty="0"/>
+              <a:t>Month, week or day. Filter by type if you like. The map stays at the bottom even when a day is quiet.</a:t>
+            </a:r>
+            <a:endParaRPr lang="en-US" sz="1700" dirty="0"/>
           </a:p>
         </p:txBody>
       </p:sp>
@@ -2886,7 +2184,7 @@
           </a:xfrm>
           <a:prstGeom prst="roundRect">
             <a:avLst>
-              <a:gd name="adj" fmla="val 5556"/>
+              <a:gd name="adj" fmla="val 6667"/>
             </a:avLst>
           </a:prstGeom>
           <a:solidFill>
@@ -2908,38 +2206,63 @@
         </p:nvSpPr>
         <p:spPr>
           <a:xfrm>
-            <a:off x="7498080" y="4754880"/>
-            <a:ext cx="4114800" cy="1371600"/>
-          </a:xfrm>
-          <a:prstGeom prst="rect">
-            <a:avLst/>
-          </a:prstGeom>
-          <a:noFill/>
-          <a:ln/>
-        </p:spPr>
-        <p:txBody>
-          <a:bodyPr wrap="square" rtlCol="0" anchor="ctr"/>
-          <a:lstStyle/>
-          <a:p>
-            <a:pPr indent="0" marL="0">
-              <a:buNone/>
-            </a:pPr>
-            <a:r>
-              <a:rPr lang="en-US" sz="1400" b="1" dirty="0">
-                <a:solidFill>
-                  <a:srgbClr val="1C1612"/>
+            <a:off x="7543800" y="4773168"/>
+            <a:ext cx="4023360" cy="1325880"/>
+          </a:xfrm>
+          <a:prstGeom prst="rect">
+            <a:avLst/>
+          </a:prstGeom>
+          <a:noFill/>
+          <a:ln/>
+        </p:spPr>
+        <p:txBody>
+          <a:bodyPr wrap="square" rtlCol="0" anchor="ctr"/>
+          <a:lstStyle/>
+          <a:p>
+            <a:pPr indent="0" marL="0">
+              <a:buNone/>
+            </a:pPr>
+            <a:r>
+              <a:rPr lang="en-US" sz="1600" dirty="0">
+                <a:solidFill>
+                  <a:srgbClr val="4A4038"/>
                 </a:solidFill>
                 <a:latin typeface="Calibri" pitchFamily="34" charset="0"/>
                 <a:ea typeface="Calibri" pitchFamily="34" charset="-122"/>
                 <a:cs typeface="Calibri" pitchFamily="34" charset="-120"/>
               </a:rPr>
-              <a:t>Try: </a:t>
-            </a:r>
-            <a:pPr indent="0" marL="0">
-              <a:buNone/>
-            </a:pPr>
-            <a:r>
-              <a:rPr lang="en-US" sz="1400" dirty="0">
+              <a:t>Try week and day for today. Tap a type, then All types — everything should come back.</a:t>
+            </a:r>
+            <a:endParaRPr lang="en-US" sz="1600" dirty="0"/>
+          </a:p>
+        </p:txBody>
+      </p:sp>
+      <p:sp>
+        <p:nvSpPr>
+          <p:cNvPr id="8" name="Text 4"/>
+          <p:cNvSpPr/>
+          <p:nvPr/>
+        </p:nvSpPr>
+        <p:spPr>
+          <a:xfrm>
+            <a:off x="457200" y="6510528"/>
+            <a:ext cx="9601200" cy="201168"/>
+          </a:xfrm>
+          <a:prstGeom prst="rect">
+            <a:avLst/>
+          </a:prstGeom>
+          <a:noFill/>
+          <a:ln/>
+        </p:spPr>
+        <p:txBody>
+          <a:bodyPr wrap="square" rtlCol="0" anchor="ctr"/>
+          <a:lstStyle/>
+          <a:p>
+            <a:pPr indent="0" marL="0">
+              <a:buNone/>
+            </a:pPr>
+            <a:r>
+              <a:rPr lang="en-US" sz="1100" dirty="0">
                 <a:solidFill>
                   <a:srgbClr val="4A4038"/>
                 </a:solidFill>
@@ -2947,46 +2270,7 @@
                 <a:ea typeface="Calibri" pitchFamily="34" charset="-122"/>
                 <a:cs typeface="Calibri" pitchFamily="34" charset="-120"/>
               </a:rPr>
-              <a:t>Week and Day for today. Christian, then All types. Online, then Any format — the map should still be there.</a:t>
-            </a:r>
-            <a:endParaRPr lang="en-US" sz="1400" dirty="0"/>
-          </a:p>
-        </p:txBody>
-      </p:sp>
-      <p:sp>
-        <p:nvSpPr>
-          <p:cNvPr id="8" name="Text 4"/>
-          <p:cNvSpPr/>
-          <p:nvPr/>
-        </p:nvSpPr>
-        <p:spPr>
-          <a:xfrm>
-            <a:off x="457200" y="6510528"/>
-            <a:ext cx="9601200" cy="201168"/>
-          </a:xfrm>
-          <a:prstGeom prst="rect">
-            <a:avLst/>
-          </a:prstGeom>
-          <a:noFill/>
-          <a:ln/>
-        </p:spPr>
-        <p:txBody>
-          <a:bodyPr wrap="square" rtlCol="0" anchor="ctr"/>
-          <a:lstStyle/>
-          <a:p>
-            <a:pPr indent="0" marL="0">
-              <a:buNone/>
-            </a:pPr>
-            <a:r>
-              <a:rPr lang="en-US" sz="1100" dirty="0">
-                <a:solidFill>
-                  <a:srgbClr val="4A4038"/>
-                </a:solidFill>
-                <a:latin typeface="Calibri" pitchFamily="34" charset="0"/>
-                <a:ea typeface="Calibri" pitchFamily="34" charset="-122"/>
-                <a:cs typeface="Calibri" pitchFamily="34" charset="-120"/>
-              </a:rPr>
-              <a:t>Gather  ·  Birmingham  ·  17 October 2026</a:t>
+              <a:t>Gather  ·  Birmingham</a:t>
             </a:r>
             <a:endParaRPr lang="en-US" sz="1100" dirty="0"/>
           </a:p>
@@ -3096,7 +2380,7 @@
                 <a:ea typeface="Georgia" pitchFamily="34" charset="-122"/>
                 <a:cs typeface="Georgia" pitchFamily="34" charset="-120"/>
               </a:rPr>
-              <a:t>Attend, then confirm</a:t>
+              <a:t>Attend, then say if you went</a:t>
             </a:r>
             <a:endParaRPr lang="en-US" sz="2800" dirty="0"/>
           </a:p>
@@ -3200,7 +2484,7 @@
         </p:nvSpPr>
         <p:spPr>
           <a:xfrm>
-            <a:off x="7772400" y="1572768"/>
+            <a:off x="7772400" y="1591056"/>
             <a:ext cx="3794760" cy="640080"/>
           </a:xfrm>
           <a:prstGeom prst="rect">
@@ -3217,7 +2501,7 @@
               <a:buNone/>
             </a:pPr>
             <a:r>
-              <a:rPr lang="en-US" sz="1500" dirty="0">
+              <a:rPr lang="en-US" sz="1600" dirty="0">
                 <a:solidFill>
                   <a:srgbClr val="4A4038"/>
                 </a:solidFill>
@@ -3225,9 +2509,9 @@
                 <a:ea typeface="Calibri" pitchFamily="34" charset="-122"/>
                 <a:cs typeface="Calibri" pitchFamily="34" charset="-120"/>
               </a:rPr>
-              <a:t>Records that you plan to go. Capacity is checked.</a:t>
-            </a:r>
-            <a:endParaRPr lang="en-US" sz="1500" dirty="0"/>
+              <a:t>Means you plan to go. That is it.</a:t>
+            </a:r>
+            <a:endParaRPr lang="en-US" sz="1600" dirty="0"/>
           </a:p>
         </p:txBody>
       </p:sp>
@@ -3278,7 +2562,7 @@
         </p:nvSpPr>
         <p:spPr>
           <a:xfrm>
-            <a:off x="7772400" y="2715768"/>
+            <a:off x="7772400" y="2734056"/>
             <a:ext cx="3794760" cy="640080"/>
           </a:xfrm>
           <a:prstGeom prst="rect">
@@ -3295,7 +2579,7 @@
               <a:buNone/>
             </a:pPr>
             <a:r>
-              <a:rPr lang="en-US" sz="1500" dirty="0">
+              <a:rPr lang="en-US" sz="1600" dirty="0">
                 <a:solidFill>
                   <a:srgbClr val="4A4038"/>
                 </a:solidFill>
@@ -3303,9 +2587,9 @@
                 <a:ea typeface="Calibri" pitchFamily="34" charset="-122"/>
                 <a:cs typeface="Calibri" pitchFamily="34" charset="-120"/>
               </a:rPr>
-              <a:t>After the event, say whether you went. That is attendance, not the click.</a:t>
-            </a:r>
-            <a:endParaRPr lang="en-US" sz="1500" dirty="0"/>
+              <a:t>After the event, a quiet prompt. Yes, no, or later.</a:t>
+            </a:r>
+            <a:endParaRPr lang="en-US" sz="1600" dirty="0"/>
           </a:p>
         </p:txBody>
       </p:sp>
@@ -3356,7 +2640,7 @@
         </p:nvSpPr>
         <p:spPr>
           <a:xfrm>
-            <a:off x="7772400" y="3858768"/>
+            <a:off x="7772400" y="3877056"/>
             <a:ext cx="3794760" cy="640080"/>
           </a:xfrm>
           <a:prstGeom prst="rect">
@@ -3373,7 +2657,7 @@
               <a:buNone/>
             </a:pPr>
             <a:r>
-              <a:rPr lang="en-US" sz="1500" dirty="0">
+              <a:rPr lang="en-US" sz="1600" dirty="0">
                 <a:solidFill>
                   <a:srgbClr val="4A4038"/>
                 </a:solidFill>
@@ -3381,9 +2665,9 @@
                 <a:ea typeface="Calibri" pitchFamily="34" charset="-122"/>
                 <a:cs typeface="Calibri" pitchFamily="34" charset="-120"/>
               </a:rPr>
-              <a:t>A bookmark. It drops after the event ends.</a:t>
-            </a:r>
-            <a:endParaRPr lang="en-US" sz="1500" dirty="0"/>
+              <a:t>A bookmark. It drops once the event is over.</a:t>
+            </a:r>
+            <a:endParaRPr lang="en-US" sz="1600" dirty="0"/>
           </a:p>
         </p:txBody>
       </p:sp>
@@ -3420,7 +2704,7 @@
                 <a:ea typeface="Georgia" pitchFamily="34" charset="-122"/>
                 <a:cs typeface="Georgia" pitchFamily="34" charset="-120"/>
               </a:rPr>
-              <a:t>Who sees names</a:t>
+              <a:t>Names</a:t>
             </a:r>
             <a:endParaRPr lang="en-US" sz="1800" dirty="0"/>
           </a:p>
@@ -3434,7 +2718,7 @@
         </p:nvSpPr>
         <p:spPr>
           <a:xfrm>
-            <a:off x="7772400" y="5001768"/>
+            <a:off x="7772400" y="5020056"/>
             <a:ext cx="3794760" cy="640080"/>
           </a:xfrm>
           <a:prstGeom prst="rect">
@@ -3451,7 +2735,7 @@
               <a:buNone/>
             </a:pPr>
             <a:r>
-              <a:rPr lang="en-US" sz="1500" dirty="0">
+              <a:rPr lang="en-US" sz="1600" dirty="0">
                 <a:solidFill>
                   <a:srgbClr val="4A4038"/>
                 </a:solidFill>
@@ -3459,9 +2743,9 @@
                 <a:ea typeface="Calibri" pitchFamily="34" charset="-122"/>
                 <a:cs typeface="Calibri" pitchFamily="34" charset="-120"/>
               </a:rPr>
-              <a:t>Admin chooses count only, initials, or name + cell.</a:t>
-            </a:r>
-            <a:endParaRPr lang="en-US" sz="1500" dirty="0"/>
+              <a:t>Members usually see a count. An admin can choose initials, or name and cell.</a:t>
+            </a:r>
+            <a:endParaRPr lang="en-US" sz="1600" dirty="0"/>
           </a:p>
         </p:txBody>
       </p:sp>
@@ -3498,7 +2782,7 @@
                 <a:ea typeface="Calibri" pitchFamily="34" charset="-122"/>
                 <a:cs typeface="Calibri" pitchFamily="34" charset="-120"/>
               </a:rPr>
-              <a:t>Gather  ·  Birmingham  ·  17 October 2026</a:t>
+              <a:t>Gather  ·  Birmingham</a:t>
             </a:r>
             <a:endParaRPr lang="en-US" sz="1100" dirty="0"/>
           </a:p>
@@ -3608,7 +2892,7 @@
                 <a:ea typeface="Georgia" pitchFamily="34" charset="-122"/>
                 <a:cs typeface="Georgia" pitchFamily="34" charset="-120"/>
               </a:rPr>
-              <a:t>Insights (admin and cell leaders)</a:t>
+              <a:t>Insights, if you lead</a:t>
             </a:r>
             <a:endParaRPr lang="en-US" sz="2800" dirty="0"/>
           </a:p>
@@ -3623,7 +2907,7 @@
         <p:spPr>
           <a:xfrm>
             <a:off x="457200" y="777240"/>
-            <a:ext cx="11247120" cy="365760"/>
+            <a:ext cx="11247120" cy="457200"/>
           </a:xfrm>
           <a:prstGeom prst="rect">
             <a:avLst/>
@@ -3647,7 +2931,7 @@
                 <a:ea typeface="Calibri" pitchFamily="34" charset="-122"/>
                 <a:cs typeface="Calibri" pitchFamily="34" charset="-120"/>
               </a:rPr>
-              <a:t>Same numbers on the page, in the file, and in a short share. Cells with fewer than three people show as &lt;3.</a:t>
+              <a:t>Admin sees the region. Cell leaders see their own cell. Members do not see this page. A file or a short share uses the same numbers as the screen.</a:t>
             </a:r>
             <a:endParaRPr lang="en-US" sz="1600" dirty="0"/>
           </a:p>
@@ -3669,8 +2953,8 @@
         </p:blipFill>
         <p:spPr>
           <a:xfrm>
-            <a:off x="457200" y="1234440"/>
-            <a:ext cx="6126480" cy="5029200"/>
+            <a:off x="457200" y="1325880"/>
+            <a:ext cx="6126480" cy="4937760"/>
           </a:xfrm>
           <a:prstGeom prst="rect">
             <a:avLst/>
@@ -3693,8 +2977,8 @@
         </p:blipFill>
         <p:spPr>
           <a:xfrm>
-            <a:off x="6766560" y="1234440"/>
-            <a:ext cx="4983480" cy="5029200"/>
+            <a:off x="6766560" y="1325880"/>
+            <a:ext cx="4983480" cy="4937760"/>
           </a:xfrm>
           <a:prstGeom prst="rect">
             <a:avLst/>
@@ -3734,7 +3018,7 @@
                 <a:ea typeface="Calibri" pitchFamily="34" charset="-122"/>
                 <a:cs typeface="Calibri" pitchFamily="34" charset="-120"/>
               </a:rPr>
-              <a:t>Gather  ·  Birmingham  ·  17 October 2026</a:t>
+              <a:t>Gather  ·  Birmingham</a:t>
             </a:r>
             <a:endParaRPr lang="en-US" sz="1100" dirty="0"/>
           </a:p>
@@ -3844,7 +3128,7 @@
                 <a:ea typeface="Georgia" pitchFamily="34" charset="-122"/>
                 <a:cs typeface="Georgia" pitchFamily="34" charset="-120"/>
               </a:rPr>
-              <a:t>What to try  ·  what this is not</a:t>
+              <a:t>Have a play</a:t>
             </a:r>
             <a:endParaRPr lang="en-US" sz="2800" dirty="0"/>
           </a:p>
@@ -3912,7 +3196,7 @@
         </p:nvSpPr>
         <p:spPr>
           <a:xfrm>
-            <a:off x="685800" y="1143000"/>
+            <a:off x="685800" y="1170432"/>
             <a:ext cx="5212080" cy="365760"/>
           </a:xfrm>
           <a:prstGeom prst="rect">
@@ -3937,7 +3221,7 @@
                 <a:ea typeface="Georgia" pitchFamily="34" charset="-122"/>
                 <a:cs typeface="Georgia" pitchFamily="34" charset="-120"/>
               </a:rPr>
-              <a:t>Please try</a:t>
+              <a:t>Nice ones to tap</a:t>
             </a:r>
             <a:endParaRPr lang="en-US" sz="2000" dirty="0"/>
           </a:p>
@@ -3951,8 +3235,8 @@
         </p:nvSpPr>
         <p:spPr>
           <a:xfrm>
-            <a:off x="685800" y="1645920"/>
-            <a:ext cx="5212080" cy="4206240"/>
+            <a:off x="685800" y="1691640"/>
+            <a:ext cx="5212080" cy="4114800"/>
           </a:xfrm>
           <a:prstGeom prst="rect">
             <a:avLst/>
@@ -3966,12 +3250,12 @@
           <a:p>
             <a:pPr indent="0" marL="0">
               <a:spcAft>
-                <a:spcPts val="1000"/>
+                <a:spcPts val="1200"/>
               </a:spcAft>
               <a:buNone/>
             </a:pPr>
             <a:r>
-              <a:rPr lang="en-US" sz="1600" dirty="0">
+              <a:rPr lang="en-US" sz="1700" dirty="0">
                 <a:solidFill>
                   <a:srgbClr val="1C1612"/>
                 </a:solidFill>
@@ -3979,19 +3263,19 @@
                 <a:ea typeface="Calibri" pitchFamily="34" charset="-122"/>
                 <a:cs typeface="Calibri" pitchFamily="34" charset="-120"/>
               </a:rPr>
-              <a:t>Week and Day show this week’s / today’s events.</a:t>
-            </a:r>
-            <a:endParaRPr lang="en-US" sz="1600" dirty="0"/>
+              <a:t>Week and day for today.</a:t>
+            </a:r>
+            <a:endParaRPr lang="en-US" sz="1700" dirty="0"/>
           </a:p>
           <a:p>
             <a:pPr indent="0" marL="0">
               <a:spcAft>
-                <a:spcPts val="1000"/>
+                <a:spcPts val="1200"/>
               </a:spcAft>
               <a:buNone/>
             </a:pPr>
             <a:r>
-              <a:rPr lang="en-US" sz="1600" dirty="0">
+              <a:rPr lang="en-US" sz="1700" dirty="0">
                 <a:solidFill>
                   <a:srgbClr val="1C1612"/>
                 </a:solidFill>
@@ -3999,19 +3283,19 @@
                 <a:ea typeface="Calibri" pitchFamily="34" charset="-122"/>
                 <a:cs typeface="Calibri" pitchFamily="34" charset="-120"/>
               </a:rPr>
-              <a:t>Christian, then All types, restores every type.</a:t>
-            </a:r>
-            <a:endParaRPr lang="en-US" sz="1600" dirty="0"/>
+              <a:t>A type chip, then All types.</a:t>
+            </a:r>
+            <a:endParaRPr lang="en-US" sz="1700" dirty="0"/>
           </a:p>
           <a:p>
             <a:pPr indent="0" marL="0">
               <a:spcAft>
-                <a:spcPts val="1000"/>
+                <a:spcPts val="1200"/>
               </a:spcAft>
               <a:buNone/>
             </a:pPr>
             <a:r>
-              <a:rPr lang="en-US" sz="1600" dirty="0">
+              <a:rPr lang="en-US" sz="1700" dirty="0">
                 <a:solidFill>
                   <a:srgbClr val="1C1612"/>
                 </a:solidFill>
@@ -4019,19 +3303,19 @@
                 <a:ea typeface="Calibri" pitchFamily="34" charset="-122"/>
                 <a:cs typeface="Calibri" pitchFamily="34" charset="-120"/>
               </a:rPr>
-              <a:t>The map is still there after Online, then Any format.</a:t>
-            </a:r>
-            <a:endParaRPr lang="en-US" sz="1600" dirty="0"/>
+              <a:t>Scroll to the map.</a:t>
+            </a:r>
+            <a:endParaRPr lang="en-US" sz="1700" dirty="0"/>
           </a:p>
           <a:p>
             <a:pPr indent="0" marL="0">
               <a:spcAft>
-                <a:spcPts val="1000"/>
+                <a:spcPts val="1200"/>
               </a:spcAft>
               <a:buNone/>
             </a:pPr>
             <a:r>
-              <a:rPr lang="en-US" sz="1600" dirty="0">
+              <a:rPr lang="en-US" sz="1700" dirty="0">
                 <a:solidFill>
                   <a:srgbClr val="1C1612"/>
                 </a:solidFill>
@@ -4039,19 +3323,19 @@
                 <a:ea typeface="Calibri" pitchFamily="34" charset="-122"/>
                 <a:cs typeface="Calibri" pitchFamily="34" charset="-120"/>
               </a:rPr>
-              <a:t>Attend as a member. Confirm later if asked.</a:t>
-            </a:r>
-            <a:endParaRPr lang="en-US" sz="1600" dirty="0"/>
+              <a:t>Open an event and click Attend.</a:t>
+            </a:r>
+            <a:endParaRPr lang="en-US" sz="1700" dirty="0"/>
           </a:p>
           <a:p>
             <a:pPr indent="0" marL="0">
               <a:spcAft>
-                <a:spcPts val="1000"/>
+                <a:spcPts val="1200"/>
               </a:spcAft>
               <a:buNone/>
             </a:pPr>
             <a:r>
-              <a:rPr lang="en-US" sz="1600" dirty="0">
+              <a:rPr lang="en-US" sz="1700" dirty="0">
                 <a:solidFill>
                   <a:srgbClr val="1C1612"/>
                 </a:solidFill>
@@ -4059,19 +3343,80 @@
                 <a:ea typeface="Calibri" pitchFamily="34" charset="-122"/>
                 <a:cs typeface="Calibri" pitchFamily="34" charset="-120"/>
               </a:rPr>
-              <a:t>Add an event: place on the map, Event Link, publish — you should land back on pending.</a:t>
-            </a:r>
-            <a:endParaRPr lang="en-US" sz="1600" dirty="0"/>
-          </a:p>
+              <a:t>If you can add events: drop a pin, add a link, publish — you should land back on pending.</a:t>
+            </a:r>
+            <a:endParaRPr lang="en-US" sz="1700" dirty="0"/>
+          </a:p>
+        </p:txBody>
+      </p:sp>
+      <p:sp>
+        <p:nvSpPr>
+          <p:cNvPr id="7" name="Text 5"/>
+          <p:cNvSpPr/>
+          <p:nvPr/>
+        </p:nvSpPr>
+        <p:spPr>
+          <a:xfrm>
+            <a:off x="6583680" y="1170432"/>
+            <a:ext cx="4937760" cy="365760"/>
+          </a:xfrm>
+          <a:prstGeom prst="rect">
+            <a:avLst/>
+          </a:prstGeom>
+          <a:noFill/>
+          <a:ln/>
+        </p:spPr>
+        <p:txBody>
+          <a:bodyPr wrap="square" rtlCol="0" anchor="ctr"/>
+          <a:lstStyle/>
+          <a:p>
+            <a:pPr indent="0" marL="0">
+              <a:buNone/>
+            </a:pPr>
+            <a:r>
+              <a:rPr lang="en-US" sz="2000" b="1" dirty="0">
+                <a:solidFill>
+                  <a:srgbClr val="8B3A24"/>
+                </a:solidFill>
+                <a:latin typeface="Georgia" pitchFamily="34" charset="0"/>
+                <a:ea typeface="Georgia" pitchFamily="34" charset="-122"/>
+                <a:cs typeface="Georgia" pitchFamily="34" charset="-120"/>
+              </a:rPr>
+              <a:t>Not this round</a:t>
+            </a:r>
+            <a:endParaRPr lang="en-US" sz="2000" dirty="0"/>
+          </a:p>
+        </p:txBody>
+      </p:sp>
+      <p:sp>
+        <p:nvSpPr>
+          <p:cNvPr id="8" name="Text 6"/>
+          <p:cNvSpPr/>
+          <p:nvPr/>
+        </p:nvSpPr>
+        <p:spPr>
+          <a:xfrm>
+            <a:off x="6583680" y="1691640"/>
+            <a:ext cx="4937760" cy="4114800"/>
+          </a:xfrm>
+          <a:prstGeom prst="rect">
+            <a:avLst/>
+          </a:prstGeom>
+          <a:noFill/>
+          <a:ln/>
+        </p:spPr>
+        <p:txBody>
+          <a:bodyPr wrap="square" rtlCol="0" anchor="ctr"/>
+          <a:lstStyle/>
           <a:p>
             <a:pPr indent="0" marL="0">
               <a:spcAft>
-                <a:spcPts val="1000"/>
+                <a:spcPts val="1200"/>
               </a:spcAft>
               <a:buNone/>
             </a:pPr>
             <a:r>
-              <a:rPr lang="en-US" sz="1600" dirty="0">
+              <a:rPr lang="en-US" sz="1700" dirty="0">
                 <a:solidFill>
                   <a:srgbClr val="1C1612"/>
                 </a:solidFill>
@@ -4079,80 +3424,19 @@
                 <a:ea typeface="Calibri" pitchFamily="34" charset="-122"/>
                 <a:cs typeface="Calibri" pitchFamily="34" charset="-120"/>
               </a:rPr>
-              <a:t>Insights: download CSV, copy the summary. Members should not see Insights.</a:t>
-            </a:r>
-            <a:endParaRPr lang="en-US" sz="1600" dirty="0"/>
-          </a:p>
-        </p:txBody>
-      </p:sp>
-      <p:sp>
-        <p:nvSpPr>
-          <p:cNvPr id="7" name="Text 5"/>
-          <p:cNvSpPr/>
-          <p:nvPr/>
-        </p:nvSpPr>
-        <p:spPr>
-          <a:xfrm>
-            <a:off x="6583680" y="1143000"/>
-            <a:ext cx="4937760" cy="365760"/>
-          </a:xfrm>
-          <a:prstGeom prst="rect">
-            <a:avLst/>
-          </a:prstGeom>
-          <a:noFill/>
-          <a:ln/>
-        </p:spPr>
-        <p:txBody>
-          <a:bodyPr wrap="square" rtlCol="0" anchor="ctr"/>
-          <a:lstStyle/>
-          <a:p>
-            <a:pPr indent="0" marL="0">
-              <a:buNone/>
-            </a:pPr>
-            <a:r>
-              <a:rPr lang="en-US" sz="2000" b="1" dirty="0">
-                <a:solidFill>
-                  <a:srgbClr val="8B3A24"/>
-                </a:solidFill>
-                <a:latin typeface="Georgia" pitchFamily="34" charset="0"/>
-                <a:ea typeface="Georgia" pitchFamily="34" charset="-122"/>
-                <a:cs typeface="Georgia" pitchFamily="34" charset="-120"/>
-              </a:rPr>
-              <a:t>Not in this phase</a:t>
-            </a:r>
-            <a:endParaRPr lang="en-US" sz="2000" dirty="0"/>
-          </a:p>
-        </p:txBody>
-      </p:sp>
-      <p:sp>
-        <p:nvSpPr>
-          <p:cNvPr id="8" name="Text 6"/>
-          <p:cNvSpPr/>
-          <p:nvPr/>
-        </p:nvSpPr>
-        <p:spPr>
-          <a:xfrm>
-            <a:off x="6583680" y="1645920"/>
-            <a:ext cx="4937760" cy="4206240"/>
-          </a:xfrm>
-          <a:prstGeom prst="rect">
-            <a:avLst/>
-          </a:prstGeom>
-          <a:noFill/>
-          <a:ln/>
-        </p:spPr>
-        <p:txBody>
-          <a:bodyPr wrap="square" rtlCol="0" anchor="ctr"/>
-          <a:lstStyle/>
+              <a:t>No public sign-up, email or texts from Gather.</a:t>
+            </a:r>
+            <a:endParaRPr lang="en-US" sz="1700" dirty="0"/>
+          </a:p>
           <a:p>
             <a:pPr indent="0" marL="0">
               <a:spcAft>
-                <a:spcPts val="1000"/>
+                <a:spcPts val="1200"/>
               </a:spcAft>
               <a:buNone/>
             </a:pPr>
             <a:r>
-              <a:rPr lang="en-US" sz="1600" dirty="0">
+              <a:rPr lang="en-US" sz="1700" dirty="0">
                 <a:solidFill>
                   <a:srgbClr val="1C1612"/>
                 </a:solidFill>
@@ -4160,19 +3444,19 @@
                 <a:ea typeface="Calibri" pitchFamily="34" charset="-122"/>
                 <a:cs typeface="Calibri" pitchFamily="34" charset="-120"/>
               </a:rPr>
-              <a:t>Public sign-up, email or SMS from Gather, member password reset.</a:t>
-            </a:r>
-            <a:endParaRPr lang="en-US" sz="1600" dirty="0"/>
+              <a:t>Share opens your own app. Gather does not send the message.</a:t>
+            </a:r>
+            <a:endParaRPr lang="en-US" sz="1700" dirty="0"/>
           </a:p>
           <a:p>
             <a:pPr indent="0" marL="0">
               <a:spcAft>
-                <a:spcPts val="1000"/>
+                <a:spcPts val="1200"/>
               </a:spcAft>
               <a:buNone/>
             </a:pPr>
             <a:r>
-              <a:rPr lang="en-US" sz="1600" dirty="0">
+              <a:rPr lang="en-US" sz="1700" dirty="0">
                 <a:solidFill>
                   <a:srgbClr val="1C1612"/>
                 </a:solidFill>
@@ -4180,19 +3464,19 @@
                 <a:ea typeface="Calibri" pitchFamily="34" charset="-122"/>
                 <a:cs typeface="Calibri" pitchFamily="34" charset="-120"/>
               </a:rPr>
-              <a:t>Live website scrape (fixtures only).</a:t>
-            </a:r>
-            <a:endParaRPr lang="en-US" sz="1600" dirty="0"/>
+              <a:t>The phone-first look is still to come. This demo is the cream paper one.</a:t>
+            </a:r>
+            <a:endParaRPr lang="en-US" sz="1700" dirty="0"/>
           </a:p>
           <a:p>
             <a:pPr indent="0" marL="0">
               <a:spcAft>
-                <a:spcPts val="1000"/>
+                <a:spcPts val="1200"/>
               </a:spcAft>
               <a:buNone/>
             </a:pPr>
             <a:r>
-              <a:rPr lang="en-US" sz="1600" dirty="0">
+              <a:rPr lang="en-US" sz="1700" dirty="0">
                 <a:solidFill>
                   <a:srgbClr val="1C1612"/>
                 </a:solidFill>
@@ -4200,86 +3484,46 @@
                 <a:ea typeface="Calibri" pitchFamily="34" charset="-122"/>
                 <a:cs typeface="Calibri" pitchFamily="34" charset="-120"/>
               </a:rPr>
-              <a:t>Phone-first redesign (section 16) — this demo is the cream paper look.</a:t>
-            </a:r>
-            <a:endParaRPr lang="en-US" sz="1600" dirty="0"/>
-          </a:p>
-          <a:p>
-            <a:pPr indent="0" marL="0">
-              <a:spcAft>
-                <a:spcPts val="1000"/>
-              </a:spcAft>
-              <a:buNone/>
-            </a:pPr>
-            <a:r>
-              <a:rPr lang="en-US" sz="1600" dirty="0">
-                <a:solidFill>
-                  <a:srgbClr val="1C1612"/>
+              <a:t>If something feels off, say so. That is the point of looking.</a:t>
+            </a:r>
+            <a:endParaRPr lang="en-US" sz="1700" dirty="0"/>
+          </a:p>
+        </p:txBody>
+      </p:sp>
+      <p:sp>
+        <p:nvSpPr>
+          <p:cNvPr id="9" name="Text 7"/>
+          <p:cNvSpPr/>
+          <p:nvPr/>
+        </p:nvSpPr>
+        <p:spPr>
+          <a:xfrm>
+            <a:off x="457200" y="6510528"/>
+            <a:ext cx="9601200" cy="201168"/>
+          </a:xfrm>
+          <a:prstGeom prst="rect">
+            <a:avLst/>
+          </a:prstGeom>
+          <a:noFill/>
+          <a:ln/>
+        </p:spPr>
+        <p:txBody>
+          <a:bodyPr wrap="square" rtlCol="0" anchor="ctr"/>
+          <a:lstStyle/>
+          <a:p>
+            <a:pPr indent="0" marL="0">
+              <a:buNone/>
+            </a:pPr>
+            <a:r>
+              <a:rPr lang="en-US" sz="1100" dirty="0">
+                <a:solidFill>
+                  <a:srgbClr val="4A4038"/>
                 </a:solidFill>
                 <a:latin typeface="Calibri" pitchFamily="34" charset="0"/>
                 <a:ea typeface="Calibri" pitchFamily="34" charset="-122"/>
                 <a:cs typeface="Calibri" pitchFamily="34" charset="-120"/>
               </a:rPr>
-              <a:t>Share opens your own app. Gather does not send the message.</a:t>
-            </a:r>
-            <a:endParaRPr lang="en-US" sz="1600" dirty="0"/>
-          </a:p>
-          <a:p>
-            <a:pPr indent="0" marL="0">
-              <a:spcAft>
-                <a:spcPts val="1000"/>
-              </a:spcAft>
-              <a:buNone/>
-            </a:pPr>
-            <a:r>
-              <a:rPr lang="en-US" sz="1600" dirty="0">
-                <a:solidFill>
-                  <a:srgbClr val="1C1612"/>
-                </a:solidFill>
-                <a:latin typeface="Calibri" pitchFamily="34" charset="0"/>
-                <a:ea typeface="Calibri" pitchFamily="34" charset="-122"/>
-                <a:cs typeface="Calibri" pitchFamily="34" charset="-120"/>
-              </a:rPr>
-              <a:t>Sign-off on docs/FUNCTIONAL.md is still for Guillaume.</a:t>
-            </a:r>
-            <a:endParaRPr lang="en-US" sz="1600" dirty="0"/>
-          </a:p>
-        </p:txBody>
-      </p:sp>
-      <p:sp>
-        <p:nvSpPr>
-          <p:cNvPr id="9" name="Text 7"/>
-          <p:cNvSpPr/>
-          <p:nvPr/>
-        </p:nvSpPr>
-        <p:spPr>
-          <a:xfrm>
-            <a:off x="457200" y="6510528"/>
-            <a:ext cx="9601200" cy="201168"/>
-          </a:xfrm>
-          <a:prstGeom prst="rect">
-            <a:avLst/>
-          </a:prstGeom>
-          <a:noFill/>
-          <a:ln/>
-        </p:spPr>
-        <p:txBody>
-          <a:bodyPr wrap="square" rtlCol="0" anchor="ctr"/>
-          <a:lstStyle/>
-          <a:p>
-            <a:pPr indent="0" marL="0">
-              <a:buNone/>
-            </a:pPr>
-            <a:r>
-              <a:rPr lang="en-US" sz="1100" dirty="0">
-                <a:solidFill>
-                  <a:srgbClr val="4A4038"/>
-                </a:solidFill>
-                <a:latin typeface="Calibri" pitchFamily="34" charset="0"/>
-                <a:ea typeface="Calibri" pitchFamily="34" charset="-122"/>
-                <a:cs typeface="Calibri" pitchFamily="34" charset="-120"/>
-              </a:rPr>
-              <a:t>Gather  ·  Birmingham  ·  17 October 2026</a:t>
+              <a:t>Gather  ·  Birmingham</a:t>
             </a:r>
             <a:endParaRPr lang="en-US" sz="1100" dirty="0"/>
           </a:p>

</xml_diff>

<commit_message>
Meet the evening tester notes: multi-select types, login dropdown, and kinder event flows.
Week and day stay a list with view tabs so they are not mistaken for filters. Pending is tiles by day. Leaders can add from a date, find a place on the map, and export events across a range.

Co-authored-by: Cursor <cursoragent@cursor.com>
</commit_message>
<xml_diff>
--- a/docs/presentation/Gather-tester-guide.pptx
+++ b/docs/presentation/Gather-tester-guide.pptx
@@ -1929,7 +1929,7 @@
                 <a:ea typeface="Calibri" pitchFamily="34" charset="-122"/>
                 <a:cs typeface="Calibri" pitchFamily="34" charset="-120"/>
               </a:rPr>
-              <a:t>Sets people up, runs the scraper, sees the whole region.</a:t>
+              <a:t>Sets people up, runs the harvest, sees the whole region.</a:t>
             </a:r>
             <a:endParaRPr lang="en-US" sz="1600" dirty="0"/>
           </a:p>
@@ -3235,8 +3235,8 @@
         </p:nvSpPr>
         <p:spPr>
           <a:xfrm>
-            <a:off x="685800" y="1691640"/>
-            <a:ext cx="5212080" cy="4114800"/>
+            <a:off x="685800" y="1600200"/>
+            <a:ext cx="5212080" cy="4297680"/>
           </a:xfrm>
           <a:prstGeom prst="rect">
             <a:avLst/>
@@ -3250,12 +3250,12 @@
           <a:p>
             <a:pPr indent="0" marL="0">
               <a:spcAft>
-                <a:spcPts val="1200"/>
+                <a:spcPts val="1000"/>
               </a:spcAft>
               <a:buNone/>
             </a:pPr>
             <a:r>
-              <a:rPr lang="en-US" sz="1700" dirty="0">
+              <a:rPr lang="en-US" sz="1600" dirty="0">
                 <a:solidFill>
                   <a:srgbClr val="1C1612"/>
                 </a:solidFill>
@@ -3263,19 +3263,19 @@
                 <a:ea typeface="Calibri" pitchFamily="34" charset="-122"/>
                 <a:cs typeface="Calibri" pitchFamily="34" charset="-120"/>
               </a:rPr>
-              <a:t>Week and day for today.</a:t>
-            </a:r>
-            <a:endParaRPr lang="en-US" sz="1700" dirty="0"/>
+              <a:t>Week and day for today — a list, not a tiny month.</a:t>
+            </a:r>
+            <a:endParaRPr lang="en-US" sz="1600" dirty="0"/>
           </a:p>
           <a:p>
             <a:pPr indent="0" marL="0">
               <a:spcAft>
-                <a:spcPts val="1200"/>
+                <a:spcPts val="1000"/>
               </a:spcAft>
               <a:buNone/>
             </a:pPr>
             <a:r>
-              <a:rPr lang="en-US" sz="1700" dirty="0">
+              <a:rPr lang="en-US" sz="1600" dirty="0">
                 <a:solidFill>
                   <a:srgbClr val="1C1612"/>
                 </a:solidFill>
@@ -3283,19 +3283,19 @@
                 <a:ea typeface="Calibri" pitchFamily="34" charset="-122"/>
                 <a:cs typeface="Calibri" pitchFamily="34" charset="-120"/>
               </a:rPr>
-              <a:t>A type chip, then All types.</a:t>
-            </a:r>
-            <a:endParaRPr lang="en-US" sz="1700" dirty="0"/>
+              <a:t>One type or two, then All types.</a:t>
+            </a:r>
+            <a:endParaRPr lang="en-US" sz="1600" dirty="0"/>
           </a:p>
           <a:p>
             <a:pPr indent="0" marL="0">
               <a:spcAft>
-                <a:spcPts val="1200"/>
+                <a:spcPts val="1000"/>
               </a:spcAft>
               <a:buNone/>
             </a:pPr>
             <a:r>
-              <a:rPr lang="en-US" sz="1700" dirty="0">
+              <a:rPr lang="en-US" sz="1600" dirty="0">
                 <a:solidFill>
                   <a:srgbClr val="1C1612"/>
                 </a:solidFill>
@@ -3305,17 +3305,17 @@
               </a:rPr>
               <a:t>Scroll to the map.</a:t>
             </a:r>
-            <a:endParaRPr lang="en-US" sz="1700" dirty="0"/>
+            <a:endParaRPr lang="en-US" sz="1600" dirty="0"/>
           </a:p>
           <a:p>
             <a:pPr indent="0" marL="0">
               <a:spcAft>
-                <a:spcPts val="1200"/>
+                <a:spcPts val="1000"/>
               </a:spcAft>
               <a:buNone/>
             </a:pPr>
             <a:r>
-              <a:rPr lang="en-US" sz="1700" dirty="0">
+              <a:rPr lang="en-US" sz="1600" dirty="0">
                 <a:solidFill>
                   <a:srgbClr val="1C1612"/>
                 </a:solidFill>
@@ -3325,17 +3325,17 @@
               </a:rPr>
               <a:t>Open an event and click Attend.</a:t>
             </a:r>
-            <a:endParaRPr lang="en-US" sz="1700" dirty="0"/>
+            <a:endParaRPr lang="en-US" sz="1600" dirty="0"/>
           </a:p>
           <a:p>
             <a:pPr indent="0" marL="0">
               <a:spcAft>
-                <a:spcPts val="1200"/>
+                <a:spcPts val="1000"/>
               </a:spcAft>
               <a:buNone/>
             </a:pPr>
             <a:r>
-              <a:rPr lang="en-US" sz="1700" dirty="0">
+              <a:rPr lang="en-US" sz="1600" dirty="0">
                 <a:solidFill>
                   <a:srgbClr val="1C1612"/>
                 </a:solidFill>
@@ -3343,9 +3343,49 @@
                 <a:ea typeface="Calibri" pitchFamily="34" charset="-122"/>
                 <a:cs typeface="Calibri" pitchFamily="34" charset="-120"/>
               </a:rPr>
-              <a:t>If you can add events: drop a pin, add a link, publish — you should land back on pending.</a:t>
-            </a:r>
-            <a:endParaRPr lang="en-US" sz="1700" dirty="0"/>
+              <a:t>If you review events: pending is by day. Publish or discard — you land back there.</a:t>
+            </a:r>
+            <a:endParaRPr lang="en-US" sz="1600" dirty="0"/>
+          </a:p>
+          <a:p>
+            <a:pPr indent="0" marL="0">
+              <a:spcAft>
+                <a:spcPts val="1000"/>
+              </a:spcAft>
+              <a:buNone/>
+            </a:pPr>
+            <a:r>
+              <a:rPr lang="en-US" sz="1600" dirty="0">
+                <a:solidFill>
+                  <a:srgbClr val="1C1612"/>
+                </a:solidFill>
+                <a:latin typeface="Calibri" pitchFamily="34" charset="0"/>
+                <a:ea typeface="Calibri" pitchFamily="34" charset="-122"/>
+                <a:cs typeface="Calibri" pitchFamily="34" charset="-120"/>
+              </a:rPr>
+              <a:t>If you admin: Run now. Demo events go to pending. Members only see what you publish.</a:t>
+            </a:r>
+            <a:endParaRPr lang="en-US" sz="1600" dirty="0"/>
+          </a:p>
+          <a:p>
+            <a:pPr indent="0" marL="0">
+              <a:spcAft>
+                <a:spcPts val="1000"/>
+              </a:spcAft>
+              <a:buNone/>
+            </a:pPr>
+            <a:r>
+              <a:rPr lang="en-US" sz="1600" dirty="0">
+                <a:solidFill>
+                  <a:srgbClr val="1C1612"/>
+                </a:solidFill>
+                <a:latin typeface="Calibri" pitchFamily="34" charset="0"/>
+                <a:ea typeface="Calibri" pitchFamily="34" charset="-122"/>
+                <a:cs typeface="Calibri" pitchFamily="34" charset="-120"/>
+              </a:rPr>
+              <a:t>Save a published event, Run now again — your wording should stay.</a:t>
+            </a:r>
+            <a:endParaRPr lang="en-US" sz="1600" dirty="0"/>
           </a:p>
         </p:txBody>
       </p:sp>
@@ -3396,8 +3436,8 @@
         </p:nvSpPr>
         <p:spPr>
           <a:xfrm>
-            <a:off x="6583680" y="1691640"/>
-            <a:ext cx="4937760" cy="4114800"/>
+            <a:off x="6583680" y="1600200"/>
+            <a:ext cx="4937760" cy="4297680"/>
           </a:xfrm>
           <a:prstGeom prst="rect">
             <a:avLst/>
@@ -3411,12 +3451,12 @@
           <a:p>
             <a:pPr indent="0" marL="0">
               <a:spcAft>
-                <a:spcPts val="1200"/>
+                <a:spcPts val="1000"/>
               </a:spcAft>
               <a:buNone/>
             </a:pPr>
             <a:r>
-              <a:rPr lang="en-US" sz="1700" dirty="0">
+              <a:rPr lang="en-US" sz="1600" dirty="0">
                 <a:solidFill>
                   <a:srgbClr val="1C1612"/>
                 </a:solidFill>
@@ -3426,17 +3466,17 @@
               </a:rPr>
               <a:t>No public sign-up, email or texts from Gather.</a:t>
             </a:r>
-            <a:endParaRPr lang="en-US" sz="1700" dirty="0"/>
+            <a:endParaRPr lang="en-US" sz="1600" dirty="0"/>
           </a:p>
           <a:p>
             <a:pPr indent="0" marL="0">
               <a:spcAft>
-                <a:spcPts val="1200"/>
+                <a:spcPts val="1000"/>
               </a:spcAft>
               <a:buNone/>
             </a:pPr>
             <a:r>
-              <a:rPr lang="en-US" sz="1700" dirty="0">
+              <a:rPr lang="en-US" sz="1600" dirty="0">
                 <a:solidFill>
                   <a:srgbClr val="1C1612"/>
                 </a:solidFill>
@@ -3444,19 +3484,19 @@
                 <a:ea typeface="Calibri" pitchFamily="34" charset="-122"/>
                 <a:cs typeface="Calibri" pitchFamily="34" charset="-120"/>
               </a:rPr>
-              <a:t>Share opens your own app. Gather does not send the message.</a:t>
-            </a:r>
-            <a:endParaRPr lang="en-US" sz="1700" dirty="0"/>
+              <a:t>Gather does not crawl the open web. A calendar feed is optional, later.</a:t>
+            </a:r>
+            <a:endParaRPr lang="en-US" sz="1600" dirty="0"/>
           </a:p>
           <a:p>
             <a:pPr indent="0" marL="0">
               <a:spcAft>
-                <a:spcPts val="1200"/>
+                <a:spcPts val="1000"/>
               </a:spcAft>
               <a:buNone/>
             </a:pPr>
             <a:r>
-              <a:rPr lang="en-US" sz="1700" dirty="0">
+              <a:rPr lang="en-US" sz="1600" dirty="0">
                 <a:solidFill>
                   <a:srgbClr val="1C1612"/>
                 </a:solidFill>
@@ -3464,19 +3504,19 @@
                 <a:ea typeface="Calibri" pitchFamily="34" charset="-122"/>
                 <a:cs typeface="Calibri" pitchFamily="34" charset="-120"/>
               </a:rPr>
-              <a:t>The phone-first look is still to come. This demo is the cream paper one.</a:t>
-            </a:r>
-            <a:endParaRPr lang="en-US" sz="1700" dirty="0"/>
+              <a:t>Share opens your own app. Gather does not send the message.</a:t>
+            </a:r>
+            <a:endParaRPr lang="en-US" sz="1600" dirty="0"/>
           </a:p>
           <a:p>
             <a:pPr indent="0" marL="0">
               <a:spcAft>
-                <a:spcPts val="1200"/>
+                <a:spcPts val="1000"/>
               </a:spcAft>
               <a:buNone/>
             </a:pPr>
             <a:r>
-              <a:rPr lang="en-US" sz="1700" dirty="0">
+              <a:rPr lang="en-US" sz="1600" dirty="0">
                 <a:solidFill>
                   <a:srgbClr val="1C1612"/>
                 </a:solidFill>
@@ -3484,9 +3524,29 @@
                 <a:ea typeface="Calibri" pitchFamily="34" charset="-122"/>
                 <a:cs typeface="Calibri" pitchFamily="34" charset="-120"/>
               </a:rPr>
+              <a:t>The phone-first look is still to come. This demo is the cream paper one.</a:t>
+            </a:r>
+            <a:endParaRPr lang="en-US" sz="1600" dirty="0"/>
+          </a:p>
+          <a:p>
+            <a:pPr indent="0" marL="0">
+              <a:spcAft>
+                <a:spcPts val="1000"/>
+              </a:spcAft>
+              <a:buNone/>
+            </a:pPr>
+            <a:r>
+              <a:rPr lang="en-US" sz="1600" dirty="0">
+                <a:solidFill>
+                  <a:srgbClr val="1C1612"/>
+                </a:solidFill>
+                <a:latin typeface="Calibri" pitchFamily="34" charset="0"/>
+                <a:ea typeface="Calibri" pitchFamily="34" charset="-122"/>
+                <a:cs typeface="Calibri" pitchFamily="34" charset="-120"/>
+              </a:rPr>
               <a:t>If something feels off, say so. That is the point of looking.</a:t>
             </a:r>
-            <a:endParaRPr lang="en-US" sz="1700" dirty="0"/>
+            <a:endParaRPr lang="en-US" sz="1600" dirty="0"/>
           </a:p>
         </p:txBody>
       </p:sp>

</xml_diff>